<commit_message>
F1 : les sept familles d'exercices manquaient
Relu après coup : le diaporama disait le chemin d'un module, le moment de la
règle et ce que la machine refuse — mais pas la décision qui se voit le plus
en classe. Sept formes d'exercices sur 87 modules et huit niveaux, jamais une
huitième.

C'est une décision didactique, pas une économie de production : un élève de
francisation dépense beaucoup d'énergie à comprendre ce qu'on lui demande. Il
l'apprend une fois. La contrainte coûte cher à l'écriture — il faut faire
entrer une intention du programme dans une forme qui existe déjà — et c'est
l'élève qui encaisse la différence quand on ne la tient pas.

Une diapositive de règle, pas d'énumération : les sept sont déjà montrées en
images dans l'annexe A2.

Co-Authored-By: Claude Opus 5 <noreply@anthropic.com>
</commit_message>
<xml_diff>
--- a/assets/presentations/diaporamas/F1-la-logique-pedagogique.pptx
+++ b/assets/presentations/diaporamas/F1-la-logique-pedagogique.pptx
@@ -20,6 +20,7 @@
     <p:sldId id="268" r:id="rId20"/>
     <p:sldId id="269" r:id="rId21"/>
     <p:sldId id="270" r:id="rId22"/>
+    <p:sldId id="271" r:id="rId23"/>
   </p:sldIdLst>
   <p:sldSz cx="12191695" cy="6858000" type="screen4x3"/>
   <p:notesSz cx="6858000" cy="9144000"/>
@@ -586,7 +587,7 @@
           <a:lstStyle/>
           <a:p>
             <a:r>
-              <a:t>La phrase porteuse est le détail que les enseignants relèvent : c'est exactement ce qu'ils font en classe quand ils refusent de faire répéter un mot seul.</a:t>
+              <a:t>Le point que les enseignants comprennent le plus vite : un élève adulte qui sait qu'on l'observe ne s'enregistre pas. Celui qui sait que personne n'écoute recommence jusqu'à être content.</a:t>
             </a:r>
           </a:p>
         </p:txBody>
@@ -656,7 +657,7 @@
           <a:lstStyle/>
           <a:p>
             <a:r>
-              <a:t>Deux moteurs de mémorisation feraient deux progressions qui divergent. Et reconnaître n'est pas savoir : on écrit.</a:t>
+              <a:t>La phrase porteuse est le détail que les enseignants relèvent : c'est exactement ce qu'ils font en classe quand ils refusent de faire répéter un mot seul.</a:t>
             </a:r>
           </a:p>
         </p:txBody>
@@ -726,7 +727,7 @@
           <a:lstStyle/>
           <a:p>
             <a:r>
-              <a:t>Ces trois refus sont écrits dans les consignes envoyées au modèle, pas dans une politique d'usage. Si on demande à voir, on peut montrer le fichier.</a:t>
+              <a:t>Deux moteurs de mémorisation feraient deux progressions qui divergent. Et reconnaître n'est pas savoir : on écrit.</a:t>
             </a:r>
           </a:p>
         </p:txBody>
@@ -796,7 +797,7 @@
           <a:lstStyle/>
           <a:p>
             <a:r>
-              <a:t>À dire fermement : ce n'est pas une fonctionnalité manquante. Diagnostiquer est le métier, et une machine qui range des élèves dans des cases se trompe sur ceux qui en ont le plus besoin.</a:t>
+              <a:t>Ces trois refus sont écrits dans les consignes envoyées au modèle, pas dans une politique d'usage. Si on demande à voir, on peut montrer le fichier.</a:t>
             </a:r>
           </a:p>
         </p:txBody>
@@ -866,7 +867,7 @@
           <a:lstStyle/>
           <a:p>
             <a:r>
-              <a:t>Cette diapositive répond d'avance à « vous remplacez le professeur ». Ne pas la sauter même si personne n'a posé la question — surtout si personne ne l'a posée.</a:t>
+              <a:t>À dire fermement : ce n'est pas une fonctionnalité manquante. Diagnostiquer est le métier, et une machine qui range des élèves dans des cases se trompe sur ceux qui en ont le plus besoin.</a:t>
             </a:r>
           </a:p>
         </p:txBody>
@@ -936,6 +937,76 @@
           <a:lstStyle/>
           <a:p>
             <a:r>
+              <a:t>Cette diapositive répond d'avance à « vous remplacez le professeur ». Ne pas la sauter même si personne n'a posé la question — surtout si personne ne l'a posée.</a:t>
+            </a:r>
+          </a:p>
+        </p:txBody>
+      </p:sp>
+      <p:sp>
+        <p:nvSpPr>
+          <p:cNvPr id="4" name="Slide Number Placeholder 3"/>
+          <p:cNvSpPr>
+            <a:spLocks noGrp="1"/>
+          </p:cNvSpPr>
+          <p:nvPr>
+            <p:ph type="sldNum" idx="5" sz="quarter"/>
+          </p:nvPr>
+        </p:nvSpPr>
+        <p:spPr/>
+      </p:sp>
+    </p:spTree>
+  </p:cSld>
+  <p:clrMapOvr>
+    <a:masterClrMapping/>
+  </p:clrMapOvr>
+</p:notes>
+</file>
+
+<file path=ppt/notesSlides/notesSlide16.xml><?xml version="1.0" encoding="utf-8"?>
+<p:notes xmlns:a="http://schemas.openxmlformats.org/drawingml/2006/main" xmlns:p="http://schemas.openxmlformats.org/presentationml/2006/main" xmlns:r="http://schemas.openxmlformats.org/officeDocument/2006/relationships">
+  <p:cSld>
+    <p:spTree>
+      <p:nvGrpSpPr>
+        <p:cNvPr id="1" name=""/>
+        <p:cNvGrpSpPr/>
+        <p:nvPr/>
+      </p:nvGrpSpPr>
+      <p:grpSpPr>
+        <a:xfrm>
+          <a:off x="0" y="0"/>
+          <a:ext cx="0" cy="0"/>
+          <a:chOff x="0" y="0"/>
+          <a:chExt cx="0" cy="0"/>
+        </a:xfrm>
+      </p:grpSpPr>
+      <p:sp>
+        <p:nvSpPr>
+          <p:cNvPr id="2" name="Slide Image Placeholder 1"/>
+          <p:cNvSpPr>
+            <a:spLocks noGrp="1"/>
+          </p:cNvSpPr>
+          <p:nvPr>
+            <p:ph type="sldImg" idx="2"/>
+          </p:nvPr>
+        </p:nvSpPr>
+        <p:spPr/>
+      </p:sp>
+      <p:sp>
+        <p:nvSpPr>
+          <p:cNvPr id="3" name="Notes Placeholder 2"/>
+          <p:cNvSpPr>
+            <a:spLocks noGrp="1"/>
+          </p:cNvSpPr>
+          <p:nvPr>
+            <p:ph type="body" idx="3" sz="quarter"/>
+          </p:nvPr>
+        </p:nvSpPr>
+        <p:spPr/>
+        <p:txBody>
+          <a:bodyPr/>
+          <a:lstStyle/>
+          <a:p>
+            <a:r>
               <a:t>Terminer là-dessus et se taire. C'est la seule diapositive du diaporama qui ne contient aucun chiffre, et c'est voulu.</a:t>
             </a:r>
           </a:p>
@@ -1356,7 +1427,7 @@
           <a:lstStyle/>
           <a:p>
             <a:r>
-              <a:t>C'est la décision la plus discutée du projet, et la plus facile à défendre en salle : demander qui, dans la salle, se souvient d'une règle apprise avant d'en avoir eu besoin.</a:t>
+              <a:t>La contrainte a été tenue sur les 87 modules et les huit niveaux. Elle coûte cher à l'écriture — il faut faire entrer une intention dans une forme existante — et c'est l'élève qui encaisse la différence quand on ne la tient pas. Les sept sont montrées en images dans l'annexe A2.</a:t>
             </a:r>
           </a:p>
         </p:txBody>
@@ -1426,7 +1497,7 @@
           <a:lstStyle/>
           <a:p>
             <a:r>
-              <a:t>Dire que c'est une correction, pas une intention initiale. Un projet qui raconte n'avoir jamais eu tort n'est pas crédible devant des praticiens.</a:t>
+              <a:t>C'est la décision la plus discutée du projet, et la plus facile à défendre en salle : demander qui, dans la salle, se souvient d'une règle apprise avant d'en avoir eu besoin.</a:t>
             </a:r>
           </a:p>
         </p:txBody>
@@ -1496,7 +1567,7 @@
           <a:lstStyle/>
           <a:p>
             <a:r>
-              <a:t>Le point que les enseignants comprennent le plus vite : un élève adulte qui sait qu'on l'observe ne s'enregistre pas. Celui qui sait que personne n'écoute recommence jusqu'à être content.</a:t>
+              <a:t>Dire que c'est une correction, pas une intention initiale. Un projet qui raconte n'avoir jamais eu tort n'est pas crédible devant des praticiens.</a:t>
             </a:r>
           </a:p>
         </p:txBody>
@@ -4918,64 +4989,110 @@
                 </a:solidFill>
                 <a:latin typeface="Verdana"/>
               </a:rPr>
-              <a:t>ÉCOUTER</a:t>
-            </a:r>
-          </a:p>
-        </p:txBody>
-      </p:sp>
-      <p:sp>
-        <p:nvSpPr>
-          <p:cNvPr id="6" name="TextBox 5"/>
-          <p:cNvSpPr txBox="1"/>
-          <p:nvPr/>
-        </p:nvSpPr>
-        <p:spPr>
-          <a:xfrm>
-            <a:off x="566928" y="749808"/>
-            <a:ext cx="11057839" cy="877824"/>
-          </a:xfrm>
-          <a:prstGeom prst="rect">
-            <a:avLst/>
-          </a:prstGeom>
-          <a:noFill/>
-        </p:spPr>
-        <p:txBody>
-          <a:bodyPr wrap="square" lIns="0" rIns="0" tIns="0" bIns="0" anchor="t">
-            <a:spAutoFit/>
-          </a:bodyPr>
-          <a:lstStyle/>
-          <a:p>
-            <a:pPr algn="l">
-              <a:lnSpc>
-                <a:spcPct val="115000"/>
-              </a:lnSpc>
-            </a:pPr>
-            <a:r>
-              <a:rPr sz="2900" b="1" i="0">
-                <a:solidFill>
-                  <a:srgbClr val="17181A"/>
-                </a:solidFill>
-                <a:latin typeface="Verdana"/>
-              </a:rPr>
-              <a:t>Ce qu'il a fallu pour que l'oral serve à quelque chose</a:t>
-            </a:r>
-          </a:p>
-        </p:txBody>
-      </p:sp>
-      <p:sp>
-        <p:nvSpPr>
-          <p:cNvPr id="7" name="Rounded Rectangle 6"/>
+              <a:t>LA CORRECTION ET L'ENVOI</a:t>
+            </a:r>
+          </a:p>
+        </p:txBody>
+      </p:sp>
+      <p:sp>
+        <p:nvSpPr>
+          <p:cNvPr id="6" name="Rounded Rectangle 5"/>
           <p:cNvSpPr/>
           <p:nvPr/>
         </p:nvSpPr>
         <p:spPr>
           <a:xfrm>
-            <a:off x="566928" y="1810512"/>
-            <a:ext cx="5446623" cy="2052828"/>
+            <a:off x="566928" y="1225296"/>
+            <a:ext cx="11057839" cy="1967991"/>
           </a:xfrm>
           <a:prstGeom prst="roundRect">
             <a:avLst>
-              <a:gd name="adj" fmla="val 7126"/>
+              <a:gd name="adj" fmla="val 7434"/>
+            </a:avLst>
+          </a:prstGeom>
+          <a:solidFill>
+            <a:srgbClr val="FCE9F0"/>
+          </a:solidFill>
+          <a:ln w="12700">
+            <a:solidFill>
+              <a:srgbClr val="EAEAE8"/>
+            </a:solidFill>
+          </a:ln>
+          <a:effectLst/>
+        </p:spPr>
+        <p:style>
+          <a:lnRef idx="1">
+            <a:schemeClr val="accent1"/>
+          </a:lnRef>
+          <a:fillRef idx="3">
+            <a:schemeClr val="accent1"/>
+          </a:fillRef>
+          <a:effectRef idx="2">
+            <a:schemeClr val="accent1"/>
+          </a:effectRef>
+          <a:fontRef idx="minor">
+            <a:schemeClr val="lt1"/>
+          </a:fontRef>
+        </p:style>
+        <p:txBody>
+          <a:bodyPr rtlCol="0" anchor="ctr"/>
+          <a:lstStyle/>
+          <a:p/>
+        </p:txBody>
+      </p:sp>
+      <p:sp>
+        <p:nvSpPr>
+          <p:cNvPr id="7" name="TextBox 6"/>
+          <p:cNvSpPr txBox="1"/>
+          <p:nvPr/>
+        </p:nvSpPr>
+        <p:spPr>
+          <a:xfrm>
+            <a:off x="1298448" y="1682496"/>
+            <a:ext cx="9594799" cy="1145032"/>
+          </a:xfrm>
+          <a:prstGeom prst="rect">
+            <a:avLst/>
+          </a:prstGeom>
+          <a:noFill/>
+        </p:spPr>
+        <p:txBody>
+          <a:bodyPr wrap="square" lIns="0" rIns="0" tIns="0" bIns="0" anchor="t">
+            <a:spAutoFit/>
+          </a:bodyPr>
+          <a:lstStyle/>
+          <a:p>
+            <a:pPr algn="l">
+              <a:lnSpc>
+                <a:spcPct val="122000"/>
+              </a:lnSpc>
+            </a:pPr>
+            <a:r>
+              <a:rPr sz="3400" b="1" i="0">
+                <a:solidFill>
+                  <a:srgbClr val="17181A"/>
+                </a:solidFill>
+                <a:latin typeface="Verdana"/>
+              </a:rPr>
+              <a:t>La correction est privée. L'envoi est un geste.</a:t>
+            </a:r>
+          </a:p>
+        </p:txBody>
+      </p:sp>
+      <p:sp>
+        <p:nvSpPr>
+          <p:cNvPr id="8" name="Rounded Rectangle 7"/>
+          <p:cNvSpPr/>
+          <p:nvPr/>
+        </p:nvSpPr>
+        <p:spPr>
+          <a:xfrm>
+            <a:off x="566928" y="3467607"/>
+            <a:ext cx="11057839" cy="1671827"/>
+          </a:xfrm>
+          <a:prstGeom prst="roundRect">
+            <a:avLst>
+              <a:gd name="adj" fmla="val 8751"/>
             </a:avLst>
           </a:prstGeom>
           <a:solidFill>
@@ -5010,14 +5127,14 @@
       </p:sp>
       <p:sp>
         <p:nvSpPr>
-          <p:cNvPr id="8" name="TextBox 7"/>
-          <p:cNvSpPr txBox="1"/>
-          <p:nvPr/>
-        </p:nvSpPr>
-        <p:spPr>
-          <a:xfrm>
-            <a:off x="886968" y="2084831"/>
-            <a:ext cx="4806543" cy="387096"/>
+          <p:cNvPr id="9" name="TextBox 8"/>
+          <p:cNvSpPr txBox="1"/>
+          <p:nvPr/>
+        </p:nvSpPr>
+        <p:spPr>
+          <a:xfrm>
+            <a:off x="969264" y="3741927"/>
+            <a:ext cx="10234879" cy="1214627"/>
           </a:xfrm>
           <a:prstGeom prst="rect">
             <a:avLst/>
@@ -5032,428 +5149,17 @@
           <a:p>
             <a:pPr algn="l">
               <a:lnSpc>
-                <a:spcPct val="118000"/>
-              </a:lnSpc>
-            </a:pPr>
-            <a:r>
-              <a:rPr sz="2400" b="1" i="0">
-                <a:solidFill>
-                  <a:srgbClr val="A5335F"/>
-                </a:solidFill>
-                <a:latin typeface="Verdana"/>
-              </a:rPr>
-              <a:t>Une voix par personnage</a:t>
-            </a:r>
-          </a:p>
-        </p:txBody>
-      </p:sp>
-      <p:sp>
-        <p:nvSpPr>
-          <p:cNvPr id="9" name="TextBox 8"/>
-          <p:cNvSpPr txBox="1"/>
-          <p:nvPr/>
-        </p:nvSpPr>
-        <p:spPr>
-          <a:xfrm>
-            <a:off x="886968" y="2499360"/>
-            <a:ext cx="4806543" cy="1089660"/>
-          </a:xfrm>
-          <a:prstGeom prst="rect">
-            <a:avLst/>
-          </a:prstGeom>
-          <a:noFill/>
-        </p:spPr>
-        <p:txBody>
-          <a:bodyPr wrap="square" lIns="0" rIns="0" tIns="0" bIns="0" anchor="t">
-            <a:spAutoFit/>
-          </a:bodyPr>
-          <a:lstStyle/>
-          <a:p>
-            <a:pPr algn="l">
-              <a:lnSpc>
-                <a:spcPct val="142000"/>
-              </a:lnSpc>
-            </a:pPr>
-            <a:r>
-              <a:rPr sz="1800" b="0" i="0">
-                <a:solidFill>
-                  <a:srgbClr val="3A3D40"/>
-                </a:solidFill>
-                <a:latin typeface="Verdana"/>
-              </a:rPr>
-              <a:t>Oksana et Bertrand ne sonnent pas pareil. Sans ça, l'élève ne sait pas qui parle et n'entend qu'un texte lu.</a:t>
-            </a:r>
-          </a:p>
-        </p:txBody>
-      </p:sp>
-      <p:sp>
-        <p:nvSpPr>
-          <p:cNvPr id="10" name="Rounded Rectangle 9"/>
-          <p:cNvSpPr/>
-          <p:nvPr/>
-        </p:nvSpPr>
-        <p:spPr>
-          <a:xfrm>
-            <a:off x="6178143" y="1810512"/>
-            <a:ext cx="5446623" cy="2052828"/>
-          </a:xfrm>
-          <a:prstGeom prst="roundRect">
-            <a:avLst>
-              <a:gd name="adj" fmla="val 7126"/>
-            </a:avLst>
-          </a:prstGeom>
-          <a:solidFill>
-            <a:srgbClr val="FFFFFF"/>
-          </a:solidFill>
-          <a:ln w="12700">
-            <a:solidFill>
-              <a:srgbClr val="EAEAE8"/>
-            </a:solidFill>
-          </a:ln>
-          <a:effectLst/>
-        </p:spPr>
-        <p:style>
-          <a:lnRef idx="1">
-            <a:schemeClr val="accent1"/>
-          </a:lnRef>
-          <a:fillRef idx="3">
-            <a:schemeClr val="accent1"/>
-          </a:fillRef>
-          <a:effectRef idx="2">
-            <a:schemeClr val="accent1"/>
-          </a:effectRef>
-          <a:fontRef idx="minor">
-            <a:schemeClr val="lt1"/>
-          </a:fontRef>
-        </p:style>
-        <p:txBody>
-          <a:bodyPr rtlCol="0" anchor="ctr"/>
-          <a:lstStyle/>
-          <a:p/>
-        </p:txBody>
-      </p:sp>
-      <p:sp>
-        <p:nvSpPr>
-          <p:cNvPr id="11" name="TextBox 10"/>
-          <p:cNvSpPr txBox="1"/>
-          <p:nvPr/>
-        </p:nvSpPr>
-        <p:spPr>
-          <a:xfrm>
-            <a:off x="6498183" y="2084831"/>
-            <a:ext cx="4806543" cy="387096"/>
-          </a:xfrm>
-          <a:prstGeom prst="rect">
-            <a:avLst/>
-          </a:prstGeom>
-          <a:noFill/>
-        </p:spPr>
-        <p:txBody>
-          <a:bodyPr wrap="square" lIns="0" rIns="0" tIns="0" bIns="0" anchor="t">
-            <a:spAutoFit/>
-          </a:bodyPr>
-          <a:lstStyle/>
-          <a:p>
-            <a:pPr algn="l">
-              <a:lnSpc>
-                <a:spcPct val="118000"/>
-              </a:lnSpc>
-            </a:pPr>
-            <a:r>
-              <a:rPr sz="2400" b="1" i="0">
-                <a:solidFill>
-                  <a:srgbClr val="A5335F"/>
-                </a:solidFill>
-                <a:latin typeface="Verdana"/>
-              </a:rPr>
-              <a:t>Un débit ralenti à la source</a:t>
-            </a:r>
-          </a:p>
-        </p:txBody>
-      </p:sp>
-      <p:sp>
-        <p:nvSpPr>
-          <p:cNvPr id="12" name="TextBox 11"/>
-          <p:cNvSpPr txBox="1"/>
-          <p:nvPr/>
-        </p:nvSpPr>
-        <p:spPr>
-          <a:xfrm>
-            <a:off x="6498183" y="2499360"/>
-            <a:ext cx="4806543" cy="1089660"/>
-          </a:xfrm>
-          <a:prstGeom prst="rect">
-            <a:avLst/>
-          </a:prstGeom>
-          <a:noFill/>
-        </p:spPr>
-        <p:txBody>
-          <a:bodyPr wrap="square" lIns="0" rIns="0" tIns="0" bIns="0" anchor="t">
-            <a:spAutoFit/>
-          </a:bodyPr>
-          <a:lstStyle/>
-          <a:p>
-            <a:pPr algn="l">
-              <a:lnSpc>
-                <a:spcPct val="142000"/>
-              </a:lnSpc>
-            </a:pPr>
-            <a:r>
-              <a:rPr sz="1800" b="0" i="0">
-                <a:solidFill>
-                  <a:srgbClr val="3A3D40"/>
-                </a:solidFill>
-                <a:latin typeface="Verdana"/>
-              </a:rPr>
-              <a:t>La voix enseignante est synthétisée plus lentement, pas étirée après coup — l'étirement dégrade le son et s'entend.</a:t>
-            </a:r>
-          </a:p>
-        </p:txBody>
-      </p:sp>
-      <p:sp>
-        <p:nvSpPr>
-          <p:cNvPr id="13" name="Rounded Rectangle 12"/>
-          <p:cNvSpPr/>
-          <p:nvPr/>
-        </p:nvSpPr>
-        <p:spPr>
-          <a:xfrm>
-            <a:off x="566928" y="4027932"/>
-            <a:ext cx="5446623" cy="2052828"/>
-          </a:xfrm>
-          <a:prstGeom prst="roundRect">
-            <a:avLst>
-              <a:gd name="adj" fmla="val 7126"/>
-            </a:avLst>
-          </a:prstGeom>
-          <a:solidFill>
-            <a:srgbClr val="FFFFFF"/>
-          </a:solidFill>
-          <a:ln w="12700">
-            <a:solidFill>
-              <a:srgbClr val="EAEAE8"/>
-            </a:solidFill>
-          </a:ln>
-          <a:effectLst/>
-        </p:spPr>
-        <p:style>
-          <a:lnRef idx="1">
-            <a:schemeClr val="accent1"/>
-          </a:lnRef>
-          <a:fillRef idx="3">
-            <a:schemeClr val="accent1"/>
-          </a:fillRef>
-          <a:effectRef idx="2">
-            <a:schemeClr val="accent1"/>
-          </a:effectRef>
-          <a:fontRef idx="minor">
-            <a:schemeClr val="lt1"/>
-          </a:fontRef>
-        </p:style>
-        <p:txBody>
-          <a:bodyPr rtlCol="0" anchor="ctr"/>
-          <a:lstStyle/>
-          <a:p/>
-        </p:txBody>
-      </p:sp>
-      <p:sp>
-        <p:nvSpPr>
-          <p:cNvPr id="14" name="TextBox 13"/>
-          <p:cNvSpPr txBox="1"/>
-          <p:nvPr/>
-        </p:nvSpPr>
-        <p:spPr>
-          <a:xfrm>
-            <a:off x="886968" y="4302252"/>
-            <a:ext cx="4806543" cy="387096"/>
-          </a:xfrm>
-          <a:prstGeom prst="rect">
-            <a:avLst/>
-          </a:prstGeom>
-          <a:noFill/>
-        </p:spPr>
-        <p:txBody>
-          <a:bodyPr wrap="square" lIns="0" rIns="0" tIns="0" bIns="0" anchor="t">
-            <a:spAutoFit/>
-          </a:bodyPr>
-          <a:lstStyle/>
-          <a:p>
-            <a:pPr algn="l">
-              <a:lnSpc>
-                <a:spcPct val="118000"/>
-              </a:lnSpc>
-            </a:pPr>
-            <a:r>
-              <a:rPr sz="2400" b="1" i="0">
-                <a:solidFill>
-                  <a:srgbClr val="A5335F"/>
-                </a:solidFill>
-                <a:latin typeface="Verdana"/>
-              </a:rPr>
-              <a:t>Réécouter ne coûte rien</a:t>
-            </a:r>
-          </a:p>
-        </p:txBody>
-      </p:sp>
-      <p:sp>
-        <p:nvSpPr>
-          <p:cNvPr id="15" name="TextBox 14"/>
-          <p:cNvSpPr txBox="1"/>
-          <p:nvPr/>
-        </p:nvSpPr>
-        <p:spPr>
-          <a:xfrm>
-            <a:off x="886968" y="4716780"/>
-            <a:ext cx="4806543" cy="1089660"/>
-          </a:xfrm>
-          <a:prstGeom prst="rect">
-            <a:avLst/>
-          </a:prstGeom>
-          <a:noFill/>
-        </p:spPr>
-        <p:txBody>
-          <a:bodyPr wrap="square" lIns="0" rIns="0" tIns="0" bIns="0" anchor="t">
-            <a:spAutoFit/>
-          </a:bodyPr>
-          <a:lstStyle/>
-          <a:p>
-            <a:pPr algn="l">
-              <a:lnSpc>
-                <a:spcPct val="142000"/>
-              </a:lnSpc>
-            </a:pPr>
-            <a:r>
-              <a:rPr sz="1800" b="0" i="0">
-                <a:solidFill>
-                  <a:srgbClr val="3A3D40"/>
-                </a:solidFill>
-                <a:latin typeface="Verdana"/>
-              </a:rPr>
-              <a:t>21 403 pistes audio, dans le module. L'élève réécoute une réplique quinze fois sans user la patience de personne.</a:t>
-            </a:r>
-          </a:p>
-        </p:txBody>
-      </p:sp>
-      <p:sp>
-        <p:nvSpPr>
-          <p:cNvPr id="16" name="Rounded Rectangle 15"/>
-          <p:cNvSpPr/>
-          <p:nvPr/>
-        </p:nvSpPr>
-        <p:spPr>
-          <a:xfrm>
-            <a:off x="6178143" y="4027932"/>
-            <a:ext cx="5446623" cy="2052828"/>
-          </a:xfrm>
-          <a:prstGeom prst="roundRect">
-            <a:avLst>
-              <a:gd name="adj" fmla="val 7126"/>
-            </a:avLst>
-          </a:prstGeom>
-          <a:solidFill>
-            <a:srgbClr val="FFFFFF"/>
-          </a:solidFill>
-          <a:ln w="12700">
-            <a:solidFill>
-              <a:srgbClr val="EAEAE8"/>
-            </a:solidFill>
-          </a:ln>
-          <a:effectLst/>
-        </p:spPr>
-        <p:style>
-          <a:lnRef idx="1">
-            <a:schemeClr val="accent1"/>
-          </a:lnRef>
-          <a:fillRef idx="3">
-            <a:schemeClr val="accent1"/>
-          </a:fillRef>
-          <a:effectRef idx="2">
-            <a:schemeClr val="accent1"/>
-          </a:effectRef>
-          <a:fontRef idx="minor">
-            <a:schemeClr val="lt1"/>
-          </a:fontRef>
-        </p:style>
-        <p:txBody>
-          <a:bodyPr rtlCol="0" anchor="ctr"/>
-          <a:lstStyle/>
-          <a:p/>
-        </p:txBody>
-      </p:sp>
-      <p:sp>
-        <p:nvSpPr>
-          <p:cNvPr id="17" name="TextBox 16"/>
-          <p:cNvSpPr txBox="1"/>
-          <p:nvPr/>
-        </p:nvSpPr>
-        <p:spPr>
-          <a:xfrm>
-            <a:off x="6498183" y="4302252"/>
-            <a:ext cx="4806543" cy="387096"/>
-          </a:xfrm>
-          <a:prstGeom prst="rect">
-            <a:avLst/>
-          </a:prstGeom>
-          <a:noFill/>
-        </p:spPr>
-        <p:txBody>
-          <a:bodyPr wrap="square" lIns="0" rIns="0" tIns="0" bIns="0" anchor="t">
-            <a:spAutoFit/>
-          </a:bodyPr>
-          <a:lstStyle/>
-          <a:p>
-            <a:pPr algn="l">
-              <a:lnSpc>
-                <a:spcPct val="118000"/>
-              </a:lnSpc>
-            </a:pPr>
-            <a:r>
-              <a:rPr sz="2400" b="1" i="0">
-                <a:solidFill>
-                  <a:srgbClr val="A5335F"/>
-                </a:solidFill>
-                <a:latin typeface="Verdana"/>
-              </a:rPr>
-              <a:t>Le mot dans une phrase</a:t>
-            </a:r>
-          </a:p>
-        </p:txBody>
-      </p:sp>
-      <p:sp>
-        <p:nvSpPr>
-          <p:cNvPr id="18" name="TextBox 17"/>
-          <p:cNvSpPr txBox="1"/>
-          <p:nvPr/>
-        </p:nvSpPr>
-        <p:spPr>
-          <a:xfrm>
-            <a:off x="6498183" y="4716780"/>
-            <a:ext cx="4806543" cy="1089660"/>
-          </a:xfrm>
-          <a:prstGeom prst="rect">
-            <a:avLst/>
-          </a:prstGeom>
-          <a:noFill/>
-        </p:spPr>
-        <p:txBody>
-          <a:bodyPr wrap="square" lIns="0" rIns="0" tIns="0" bIns="0" anchor="t">
-            <a:spAutoFit/>
-          </a:bodyPr>
-          <a:lstStyle/>
-          <a:p>
-            <a:pPr algn="l">
-              <a:lnSpc>
-                <a:spcPct val="142000"/>
-              </a:lnSpc>
-            </a:pPr>
-            <a:r>
-              <a:rPr sz="1800" b="0" i="0">
-                <a:solidFill>
-                  <a:srgbClr val="3A3D40"/>
-                </a:solidFill>
-                <a:latin typeface="Verdana"/>
-              </a:rPr>
-              <a:t>Un mot isolé se prononce mal et s'oublie. Chaque mot du vocabulaire est enregistré dans une phrase porteuse.</a:t>
+                <a:spcPct val="145000"/>
+              </a:lnSpc>
+            </a:pPr>
+            <a:r>
+              <a:rPr sz="2000" b="0" i="0">
+                <a:solidFill>
+                  <a:srgbClr val="4B4F52"/>
+                </a:solidFill>
+                <a:latin typeface="Verdana"/>
+              </a:rPr>
+              <a:t>Quand un élève fait relire son texte ou son enregistrement, rien n'est gardé et rien ne part. L'enseignant reçoit ce que l'élève décide de lui envoyer, quand il le décide. C'est ce qui permet de recommencer douze fois.</a:t>
             </a:r>
           </a:p>
         </p:txBody>
@@ -5630,110 +5336,64 @@
                 </a:solidFill>
                 <a:latin typeface="Verdana"/>
               </a:rPr>
-              <a:t>LE VOCABULAIRE</a:t>
-            </a:r>
-          </a:p>
-        </p:txBody>
-      </p:sp>
-      <p:sp>
-        <p:nvSpPr>
-          <p:cNvPr id="6" name="Rounded Rectangle 5"/>
+              <a:t>ÉCOUTER</a:t>
+            </a:r>
+          </a:p>
+        </p:txBody>
+      </p:sp>
+      <p:sp>
+        <p:nvSpPr>
+          <p:cNvPr id="6" name="TextBox 5"/>
+          <p:cNvSpPr txBox="1"/>
+          <p:nvPr/>
+        </p:nvSpPr>
+        <p:spPr>
+          <a:xfrm>
+            <a:off x="566928" y="749808"/>
+            <a:ext cx="11057839" cy="877824"/>
+          </a:xfrm>
+          <a:prstGeom prst="rect">
+            <a:avLst/>
+          </a:prstGeom>
+          <a:noFill/>
+        </p:spPr>
+        <p:txBody>
+          <a:bodyPr wrap="square" lIns="0" rIns="0" tIns="0" bIns="0" anchor="t">
+            <a:spAutoFit/>
+          </a:bodyPr>
+          <a:lstStyle/>
+          <a:p>
+            <a:pPr algn="l">
+              <a:lnSpc>
+                <a:spcPct val="115000"/>
+              </a:lnSpc>
+            </a:pPr>
+            <a:r>
+              <a:rPr sz="2900" b="1" i="0">
+                <a:solidFill>
+                  <a:srgbClr val="17181A"/>
+                </a:solidFill>
+                <a:latin typeface="Verdana"/>
+              </a:rPr>
+              <a:t>Ce qu'il a fallu pour que l'oral serve à quelque chose</a:t>
+            </a:r>
+          </a:p>
+        </p:txBody>
+      </p:sp>
+      <p:sp>
+        <p:nvSpPr>
+          <p:cNvPr id="7" name="Rounded Rectangle 6"/>
           <p:cNvSpPr/>
           <p:nvPr/>
         </p:nvSpPr>
         <p:spPr>
           <a:xfrm>
-            <a:off x="566928" y="1225296"/>
-            <a:ext cx="11057839" cy="1967991"/>
+            <a:off x="566928" y="1810512"/>
+            <a:ext cx="5446623" cy="2052828"/>
           </a:xfrm>
           <a:prstGeom prst="roundRect">
             <a:avLst>
-              <a:gd name="adj" fmla="val 7434"/>
-            </a:avLst>
-          </a:prstGeom>
-          <a:solidFill>
-            <a:srgbClr val="FCE9F0"/>
-          </a:solidFill>
-          <a:ln w="12700">
-            <a:solidFill>
-              <a:srgbClr val="EAEAE8"/>
-            </a:solidFill>
-          </a:ln>
-          <a:effectLst/>
-        </p:spPr>
-        <p:style>
-          <a:lnRef idx="1">
-            <a:schemeClr val="accent1"/>
-          </a:lnRef>
-          <a:fillRef idx="3">
-            <a:schemeClr val="accent1"/>
-          </a:fillRef>
-          <a:effectRef idx="2">
-            <a:schemeClr val="accent1"/>
-          </a:effectRef>
-          <a:fontRef idx="minor">
-            <a:schemeClr val="lt1"/>
-          </a:fontRef>
-        </p:style>
-        <p:txBody>
-          <a:bodyPr rtlCol="0" anchor="ctr"/>
-          <a:lstStyle/>
-          <a:p/>
-        </p:txBody>
-      </p:sp>
-      <p:sp>
-        <p:nvSpPr>
-          <p:cNvPr id="7" name="TextBox 6"/>
-          <p:cNvSpPr txBox="1"/>
-          <p:nvPr/>
-        </p:nvSpPr>
-        <p:spPr>
-          <a:xfrm>
-            <a:off x="1298448" y="1682496"/>
-            <a:ext cx="9594799" cy="1145032"/>
-          </a:xfrm>
-          <a:prstGeom prst="rect">
-            <a:avLst/>
-          </a:prstGeom>
-          <a:noFill/>
-        </p:spPr>
-        <p:txBody>
-          <a:bodyPr wrap="square" lIns="0" rIns="0" tIns="0" bIns="0" anchor="t">
-            <a:spAutoFit/>
-          </a:bodyPr>
-          <a:lstStyle/>
-          <a:p>
-            <a:pPr algn="l">
-              <a:lnSpc>
-                <a:spcPct val="122000"/>
-              </a:lnSpc>
-            </a:pPr>
-            <a:r>
-              <a:rPr sz="3400" b="1" i="0">
-                <a:solidFill>
-                  <a:srgbClr val="17181A"/>
-                </a:solidFill>
-                <a:latin typeface="Verdana"/>
-              </a:rPr>
-              <a:t>Une seule porte d'entrée dans la progression.</a:t>
-            </a:r>
-          </a:p>
-        </p:txBody>
-      </p:sp>
-      <p:sp>
-        <p:nvSpPr>
-          <p:cNvPr id="8" name="Rounded Rectangle 7"/>
-          <p:cNvSpPr/>
-          <p:nvPr/>
-        </p:nvSpPr>
-        <p:spPr>
-          <a:xfrm>
-            <a:off x="566928" y="3467607"/>
-            <a:ext cx="11057839" cy="2040128"/>
-          </a:xfrm>
-          <a:prstGeom prst="roundRect">
-            <a:avLst>
-              <a:gd name="adj" fmla="val 7171"/>
+              <a:gd name="adj" fmla="val 7126"/>
             </a:avLst>
           </a:prstGeom>
           <a:solidFill>
@@ -5768,14 +5428,53 @@
       </p:sp>
       <p:sp>
         <p:nvSpPr>
+          <p:cNvPr id="8" name="TextBox 7"/>
+          <p:cNvSpPr txBox="1"/>
+          <p:nvPr/>
+        </p:nvSpPr>
+        <p:spPr>
+          <a:xfrm>
+            <a:off x="886968" y="2084831"/>
+            <a:ext cx="4806543" cy="387096"/>
+          </a:xfrm>
+          <a:prstGeom prst="rect">
+            <a:avLst/>
+          </a:prstGeom>
+          <a:noFill/>
+        </p:spPr>
+        <p:txBody>
+          <a:bodyPr wrap="square" lIns="0" rIns="0" tIns="0" bIns="0" anchor="t">
+            <a:spAutoFit/>
+          </a:bodyPr>
+          <a:lstStyle/>
+          <a:p>
+            <a:pPr algn="l">
+              <a:lnSpc>
+                <a:spcPct val="118000"/>
+              </a:lnSpc>
+            </a:pPr>
+            <a:r>
+              <a:rPr sz="2400" b="1" i="0">
+                <a:solidFill>
+                  <a:srgbClr val="A5335F"/>
+                </a:solidFill>
+                <a:latin typeface="Verdana"/>
+              </a:rPr>
+              <a:t>Une voix par personnage</a:t>
+            </a:r>
+          </a:p>
+        </p:txBody>
+      </p:sp>
+      <p:sp>
+        <p:nvSpPr>
           <p:cNvPr id="9" name="TextBox 8"/>
           <p:cNvSpPr txBox="1"/>
           <p:nvPr/>
         </p:nvSpPr>
         <p:spPr>
           <a:xfrm>
-            <a:off x="969264" y="3741927"/>
-            <a:ext cx="10234879" cy="1582928"/>
+            <a:off x="886968" y="2499360"/>
+            <a:ext cx="4806543" cy="1089660"/>
           </a:xfrm>
           <a:prstGeom prst="rect">
             <a:avLst/>
@@ -5790,17 +5489,389 @@
           <a:p>
             <a:pPr algn="l">
               <a:lnSpc>
-                <a:spcPct val="145000"/>
-              </a:lnSpc>
-            </a:pPr>
-            <a:r>
-              <a:rPr sz="2000" b="0" i="0">
-                <a:solidFill>
-                  <a:srgbClr val="4B4F52"/>
-                </a:solidFill>
-                <a:latin typeface="Verdana"/>
-              </a:rPr>
-              <a:t>La section « Je retiens des mots » d'un module n'enregistre rien : elle fait travailler. C'est l'atelier de cartes mémoire, en répétition espacée, qui fait monter un mot d'une boîte à l'autre — et l'élève y **écrit** le mot, il ne le reconnaît pas dans une liste.</a:t>
+                <a:spcPct val="142000"/>
+              </a:lnSpc>
+            </a:pPr>
+            <a:r>
+              <a:rPr sz="1800" b="0" i="0">
+                <a:solidFill>
+                  <a:srgbClr val="3A3D40"/>
+                </a:solidFill>
+                <a:latin typeface="Verdana"/>
+              </a:rPr>
+              <a:t>Oksana et Bertrand ne sonnent pas pareil. Sans ça, l'élève ne sait pas qui parle et n'entend qu'un texte lu.</a:t>
+            </a:r>
+          </a:p>
+        </p:txBody>
+      </p:sp>
+      <p:sp>
+        <p:nvSpPr>
+          <p:cNvPr id="10" name="Rounded Rectangle 9"/>
+          <p:cNvSpPr/>
+          <p:nvPr/>
+        </p:nvSpPr>
+        <p:spPr>
+          <a:xfrm>
+            <a:off x="6178143" y="1810512"/>
+            <a:ext cx="5446623" cy="2052828"/>
+          </a:xfrm>
+          <a:prstGeom prst="roundRect">
+            <a:avLst>
+              <a:gd name="adj" fmla="val 7126"/>
+            </a:avLst>
+          </a:prstGeom>
+          <a:solidFill>
+            <a:srgbClr val="FFFFFF"/>
+          </a:solidFill>
+          <a:ln w="12700">
+            <a:solidFill>
+              <a:srgbClr val="EAEAE8"/>
+            </a:solidFill>
+          </a:ln>
+          <a:effectLst/>
+        </p:spPr>
+        <p:style>
+          <a:lnRef idx="1">
+            <a:schemeClr val="accent1"/>
+          </a:lnRef>
+          <a:fillRef idx="3">
+            <a:schemeClr val="accent1"/>
+          </a:fillRef>
+          <a:effectRef idx="2">
+            <a:schemeClr val="accent1"/>
+          </a:effectRef>
+          <a:fontRef idx="minor">
+            <a:schemeClr val="lt1"/>
+          </a:fontRef>
+        </p:style>
+        <p:txBody>
+          <a:bodyPr rtlCol="0" anchor="ctr"/>
+          <a:lstStyle/>
+          <a:p/>
+        </p:txBody>
+      </p:sp>
+      <p:sp>
+        <p:nvSpPr>
+          <p:cNvPr id="11" name="TextBox 10"/>
+          <p:cNvSpPr txBox="1"/>
+          <p:nvPr/>
+        </p:nvSpPr>
+        <p:spPr>
+          <a:xfrm>
+            <a:off x="6498183" y="2084831"/>
+            <a:ext cx="4806543" cy="387096"/>
+          </a:xfrm>
+          <a:prstGeom prst="rect">
+            <a:avLst/>
+          </a:prstGeom>
+          <a:noFill/>
+        </p:spPr>
+        <p:txBody>
+          <a:bodyPr wrap="square" lIns="0" rIns="0" tIns="0" bIns="0" anchor="t">
+            <a:spAutoFit/>
+          </a:bodyPr>
+          <a:lstStyle/>
+          <a:p>
+            <a:pPr algn="l">
+              <a:lnSpc>
+                <a:spcPct val="118000"/>
+              </a:lnSpc>
+            </a:pPr>
+            <a:r>
+              <a:rPr sz="2400" b="1" i="0">
+                <a:solidFill>
+                  <a:srgbClr val="A5335F"/>
+                </a:solidFill>
+                <a:latin typeface="Verdana"/>
+              </a:rPr>
+              <a:t>Un débit ralenti à la source</a:t>
+            </a:r>
+          </a:p>
+        </p:txBody>
+      </p:sp>
+      <p:sp>
+        <p:nvSpPr>
+          <p:cNvPr id="12" name="TextBox 11"/>
+          <p:cNvSpPr txBox="1"/>
+          <p:nvPr/>
+        </p:nvSpPr>
+        <p:spPr>
+          <a:xfrm>
+            <a:off x="6498183" y="2499360"/>
+            <a:ext cx="4806543" cy="1089660"/>
+          </a:xfrm>
+          <a:prstGeom prst="rect">
+            <a:avLst/>
+          </a:prstGeom>
+          <a:noFill/>
+        </p:spPr>
+        <p:txBody>
+          <a:bodyPr wrap="square" lIns="0" rIns="0" tIns="0" bIns="0" anchor="t">
+            <a:spAutoFit/>
+          </a:bodyPr>
+          <a:lstStyle/>
+          <a:p>
+            <a:pPr algn="l">
+              <a:lnSpc>
+                <a:spcPct val="142000"/>
+              </a:lnSpc>
+            </a:pPr>
+            <a:r>
+              <a:rPr sz="1800" b="0" i="0">
+                <a:solidFill>
+                  <a:srgbClr val="3A3D40"/>
+                </a:solidFill>
+                <a:latin typeface="Verdana"/>
+              </a:rPr>
+              <a:t>La voix enseignante est synthétisée plus lentement, pas étirée après coup — l'étirement dégrade le son et s'entend.</a:t>
+            </a:r>
+          </a:p>
+        </p:txBody>
+      </p:sp>
+      <p:sp>
+        <p:nvSpPr>
+          <p:cNvPr id="13" name="Rounded Rectangle 12"/>
+          <p:cNvSpPr/>
+          <p:nvPr/>
+        </p:nvSpPr>
+        <p:spPr>
+          <a:xfrm>
+            <a:off x="566928" y="4027932"/>
+            <a:ext cx="5446623" cy="2052828"/>
+          </a:xfrm>
+          <a:prstGeom prst="roundRect">
+            <a:avLst>
+              <a:gd name="adj" fmla="val 7126"/>
+            </a:avLst>
+          </a:prstGeom>
+          <a:solidFill>
+            <a:srgbClr val="FFFFFF"/>
+          </a:solidFill>
+          <a:ln w="12700">
+            <a:solidFill>
+              <a:srgbClr val="EAEAE8"/>
+            </a:solidFill>
+          </a:ln>
+          <a:effectLst/>
+        </p:spPr>
+        <p:style>
+          <a:lnRef idx="1">
+            <a:schemeClr val="accent1"/>
+          </a:lnRef>
+          <a:fillRef idx="3">
+            <a:schemeClr val="accent1"/>
+          </a:fillRef>
+          <a:effectRef idx="2">
+            <a:schemeClr val="accent1"/>
+          </a:effectRef>
+          <a:fontRef idx="minor">
+            <a:schemeClr val="lt1"/>
+          </a:fontRef>
+        </p:style>
+        <p:txBody>
+          <a:bodyPr rtlCol="0" anchor="ctr"/>
+          <a:lstStyle/>
+          <a:p/>
+        </p:txBody>
+      </p:sp>
+      <p:sp>
+        <p:nvSpPr>
+          <p:cNvPr id="14" name="TextBox 13"/>
+          <p:cNvSpPr txBox="1"/>
+          <p:nvPr/>
+        </p:nvSpPr>
+        <p:spPr>
+          <a:xfrm>
+            <a:off x="886968" y="4302252"/>
+            <a:ext cx="4806543" cy="387096"/>
+          </a:xfrm>
+          <a:prstGeom prst="rect">
+            <a:avLst/>
+          </a:prstGeom>
+          <a:noFill/>
+        </p:spPr>
+        <p:txBody>
+          <a:bodyPr wrap="square" lIns="0" rIns="0" tIns="0" bIns="0" anchor="t">
+            <a:spAutoFit/>
+          </a:bodyPr>
+          <a:lstStyle/>
+          <a:p>
+            <a:pPr algn="l">
+              <a:lnSpc>
+                <a:spcPct val="118000"/>
+              </a:lnSpc>
+            </a:pPr>
+            <a:r>
+              <a:rPr sz="2400" b="1" i="0">
+                <a:solidFill>
+                  <a:srgbClr val="A5335F"/>
+                </a:solidFill>
+                <a:latin typeface="Verdana"/>
+              </a:rPr>
+              <a:t>Réécouter ne coûte rien</a:t>
+            </a:r>
+          </a:p>
+        </p:txBody>
+      </p:sp>
+      <p:sp>
+        <p:nvSpPr>
+          <p:cNvPr id="15" name="TextBox 14"/>
+          <p:cNvSpPr txBox="1"/>
+          <p:nvPr/>
+        </p:nvSpPr>
+        <p:spPr>
+          <a:xfrm>
+            <a:off x="886968" y="4716780"/>
+            <a:ext cx="4806543" cy="1089660"/>
+          </a:xfrm>
+          <a:prstGeom prst="rect">
+            <a:avLst/>
+          </a:prstGeom>
+          <a:noFill/>
+        </p:spPr>
+        <p:txBody>
+          <a:bodyPr wrap="square" lIns="0" rIns="0" tIns="0" bIns="0" anchor="t">
+            <a:spAutoFit/>
+          </a:bodyPr>
+          <a:lstStyle/>
+          <a:p>
+            <a:pPr algn="l">
+              <a:lnSpc>
+                <a:spcPct val="142000"/>
+              </a:lnSpc>
+            </a:pPr>
+            <a:r>
+              <a:rPr sz="1800" b="0" i="0">
+                <a:solidFill>
+                  <a:srgbClr val="3A3D40"/>
+                </a:solidFill>
+                <a:latin typeface="Verdana"/>
+              </a:rPr>
+              <a:t>21 403 pistes audio, dans le module. L'élève réécoute une réplique quinze fois sans user la patience de personne.</a:t>
+            </a:r>
+          </a:p>
+        </p:txBody>
+      </p:sp>
+      <p:sp>
+        <p:nvSpPr>
+          <p:cNvPr id="16" name="Rounded Rectangle 15"/>
+          <p:cNvSpPr/>
+          <p:nvPr/>
+        </p:nvSpPr>
+        <p:spPr>
+          <a:xfrm>
+            <a:off x="6178143" y="4027932"/>
+            <a:ext cx="5446623" cy="2052828"/>
+          </a:xfrm>
+          <a:prstGeom prst="roundRect">
+            <a:avLst>
+              <a:gd name="adj" fmla="val 7126"/>
+            </a:avLst>
+          </a:prstGeom>
+          <a:solidFill>
+            <a:srgbClr val="FFFFFF"/>
+          </a:solidFill>
+          <a:ln w="12700">
+            <a:solidFill>
+              <a:srgbClr val="EAEAE8"/>
+            </a:solidFill>
+          </a:ln>
+          <a:effectLst/>
+        </p:spPr>
+        <p:style>
+          <a:lnRef idx="1">
+            <a:schemeClr val="accent1"/>
+          </a:lnRef>
+          <a:fillRef idx="3">
+            <a:schemeClr val="accent1"/>
+          </a:fillRef>
+          <a:effectRef idx="2">
+            <a:schemeClr val="accent1"/>
+          </a:effectRef>
+          <a:fontRef idx="minor">
+            <a:schemeClr val="lt1"/>
+          </a:fontRef>
+        </p:style>
+        <p:txBody>
+          <a:bodyPr rtlCol="0" anchor="ctr"/>
+          <a:lstStyle/>
+          <a:p/>
+        </p:txBody>
+      </p:sp>
+      <p:sp>
+        <p:nvSpPr>
+          <p:cNvPr id="17" name="TextBox 16"/>
+          <p:cNvSpPr txBox="1"/>
+          <p:nvPr/>
+        </p:nvSpPr>
+        <p:spPr>
+          <a:xfrm>
+            <a:off x="6498183" y="4302252"/>
+            <a:ext cx="4806543" cy="387096"/>
+          </a:xfrm>
+          <a:prstGeom prst="rect">
+            <a:avLst/>
+          </a:prstGeom>
+          <a:noFill/>
+        </p:spPr>
+        <p:txBody>
+          <a:bodyPr wrap="square" lIns="0" rIns="0" tIns="0" bIns="0" anchor="t">
+            <a:spAutoFit/>
+          </a:bodyPr>
+          <a:lstStyle/>
+          <a:p>
+            <a:pPr algn="l">
+              <a:lnSpc>
+                <a:spcPct val="118000"/>
+              </a:lnSpc>
+            </a:pPr>
+            <a:r>
+              <a:rPr sz="2400" b="1" i="0">
+                <a:solidFill>
+                  <a:srgbClr val="A5335F"/>
+                </a:solidFill>
+                <a:latin typeface="Verdana"/>
+              </a:rPr>
+              <a:t>Le mot dans une phrase</a:t>
+            </a:r>
+          </a:p>
+        </p:txBody>
+      </p:sp>
+      <p:sp>
+        <p:nvSpPr>
+          <p:cNvPr id="18" name="TextBox 17"/>
+          <p:cNvSpPr txBox="1"/>
+          <p:nvPr/>
+        </p:nvSpPr>
+        <p:spPr>
+          <a:xfrm>
+            <a:off x="6498183" y="4716780"/>
+            <a:ext cx="4806543" cy="1089660"/>
+          </a:xfrm>
+          <a:prstGeom prst="rect">
+            <a:avLst/>
+          </a:prstGeom>
+          <a:noFill/>
+        </p:spPr>
+        <p:txBody>
+          <a:bodyPr wrap="square" lIns="0" rIns="0" tIns="0" bIns="0" anchor="t">
+            <a:spAutoFit/>
+          </a:bodyPr>
+          <a:lstStyle/>
+          <a:p>
+            <a:pPr algn="l">
+              <a:lnSpc>
+                <a:spcPct val="142000"/>
+              </a:lnSpc>
+            </a:pPr>
+            <a:r>
+              <a:rPr sz="1800" b="0" i="0">
+                <a:solidFill>
+                  <a:srgbClr val="3A3D40"/>
+                </a:solidFill>
+                <a:latin typeface="Verdana"/>
+              </a:rPr>
+              <a:t>Un mot isolé se prononce mal et s'oublie. Chaque mot du vocabulaire est enregistré dans une phrase porteuse.</a:t>
             </a:r>
           </a:p>
         </p:txBody>
@@ -5977,72 +6048,33 @@
                 </a:solidFill>
                 <a:latin typeface="Verdana"/>
               </a:rPr>
-              <a:t>LA QUESTION QUI VIENT TOUJOURS</a:t>
-            </a:r>
-          </a:p>
-        </p:txBody>
-      </p:sp>
-      <p:sp>
-        <p:nvSpPr>
-          <p:cNvPr id="6" name="TextBox 5"/>
-          <p:cNvSpPr txBox="1"/>
-          <p:nvPr/>
-        </p:nvSpPr>
-        <p:spPr>
-          <a:xfrm>
-            <a:off x="566928" y="749808"/>
-            <a:ext cx="11057839" cy="877824"/>
-          </a:xfrm>
-          <a:prstGeom prst="rect">
-            <a:avLst/>
-          </a:prstGeom>
-          <a:noFill/>
-        </p:spPr>
-        <p:txBody>
-          <a:bodyPr wrap="square" lIns="0" rIns="0" tIns="0" bIns="0" anchor="t">
-            <a:spAutoFit/>
-          </a:bodyPr>
-          <a:lstStyle/>
-          <a:p>
-            <a:pPr algn="l">
-              <a:lnSpc>
-                <a:spcPct val="115000"/>
-              </a:lnSpc>
-            </a:pPr>
-            <a:r>
-              <a:rPr sz="3400" b="1" i="0">
-                <a:solidFill>
-                  <a:srgbClr val="17181A"/>
-                </a:solidFill>
-                <a:latin typeface="Verdana"/>
-              </a:rPr>
-              <a:t>Le piège le plus fréquent</a:t>
-            </a:r>
-          </a:p>
-        </p:txBody>
-      </p:sp>
-      <p:sp>
-        <p:nvSpPr>
-          <p:cNvPr id="7" name="Rounded Rectangle 6"/>
+              <a:t>LE VOCABULAIRE</a:t>
+            </a:r>
+          </a:p>
+        </p:txBody>
+      </p:sp>
+      <p:sp>
+        <p:nvSpPr>
+          <p:cNvPr id="6" name="Rounded Rectangle 5"/>
           <p:cNvSpPr/>
           <p:nvPr/>
         </p:nvSpPr>
         <p:spPr>
           <a:xfrm>
-            <a:off x="566928" y="1856232"/>
-            <a:ext cx="5428335" cy="2331720"/>
+            <a:off x="566928" y="1225296"/>
+            <a:ext cx="11057839" cy="1967991"/>
           </a:xfrm>
           <a:prstGeom prst="roundRect">
             <a:avLst>
-              <a:gd name="adj" fmla="val 6274"/>
+              <a:gd name="adj" fmla="val 7434"/>
             </a:avLst>
           </a:prstGeom>
           <a:solidFill>
-            <a:srgbClr val="FFF6F5"/>
+            <a:srgbClr val="FCE9F0"/>
           </a:solidFill>
           <a:ln w="12700">
             <a:solidFill>
-              <a:srgbClr val="DC2626"/>
+              <a:srgbClr val="EAEAE8"/>
             </a:solidFill>
           </a:ln>
           <a:effectLst/>
@@ -6069,14 +6101,14 @@
       </p:sp>
       <p:sp>
         <p:nvSpPr>
-          <p:cNvPr id="8" name="TextBox 7"/>
-          <p:cNvSpPr txBox="1"/>
-          <p:nvPr/>
-        </p:nvSpPr>
-        <p:spPr>
-          <a:xfrm>
-            <a:off x="932688" y="2130552"/>
-            <a:ext cx="4696815" cy="274320"/>
+          <p:cNvPr id="7" name="TextBox 6"/>
+          <p:cNvSpPr txBox="1"/>
+          <p:nvPr/>
+        </p:nvSpPr>
+        <p:spPr>
+          <a:xfrm>
+            <a:off x="1298448" y="1682496"/>
+            <a:ext cx="9594799" cy="1145032"/>
           </a:xfrm>
           <a:prstGeom prst="rect">
             <a:avLst/>
@@ -6091,198 +6123,35 @@
           <a:p>
             <a:pPr algn="l">
               <a:lnSpc>
-                <a:spcPct val="135000"/>
-              </a:lnSpc>
-            </a:pPr>
-            <a:r>
-              <a:rPr sz="1300" b="1" i="0" spc="156">
-                <a:solidFill>
-                  <a:srgbClr val="B91C1C"/>
-                </a:solidFill>
-                <a:latin typeface="Verdana"/>
-              </a:rPr>
-              <a:t>ON ENTEND SOUVENT</a:t>
-            </a:r>
-          </a:p>
-        </p:txBody>
-      </p:sp>
-      <p:sp>
-        <p:nvSpPr>
-          <p:cNvPr id="9" name="TextBox 8"/>
-          <p:cNvSpPr txBox="1"/>
-          <p:nvPr/>
-        </p:nvSpPr>
-        <p:spPr>
-          <a:xfrm>
-            <a:off x="932688" y="2569464"/>
-            <a:ext cx="4696815" cy="1417320"/>
-          </a:xfrm>
-          <a:prstGeom prst="rect">
-            <a:avLst/>
-          </a:prstGeom>
-          <a:noFill/>
-        </p:spPr>
-        <p:txBody>
-          <a:bodyPr wrap="square" lIns="0" rIns="0" tIns="0" bIns="0" anchor="t">
-            <a:spAutoFit/>
-          </a:bodyPr>
-          <a:lstStyle/>
-          <a:p>
-            <a:pPr algn="l">
-              <a:lnSpc>
-                <a:spcPct val="130000"/>
-              </a:lnSpc>
-            </a:pPr>
-            <a:r>
-              <a:rPr sz="2500" b="1" i="0">
+                <a:spcPct val="122000"/>
+              </a:lnSpc>
+            </a:pPr>
+            <a:r>
+              <a:rPr sz="3400" b="1" i="0">
                 <a:solidFill>
                   <a:srgbClr val="17181A"/>
                 </a:solidFill>
                 <a:latin typeface="Verdana"/>
               </a:rPr>
-              <a:t>« Votre assistant va faire les exercices à leur place. »</a:t>
-            </a:r>
-          </a:p>
-        </p:txBody>
-      </p:sp>
-      <p:sp>
-        <p:nvSpPr>
-          <p:cNvPr id="10" name="Rounded Rectangle 9"/>
+              <a:t>Une seule porte d'entrée dans la progression.</a:t>
+            </a:r>
+          </a:p>
+        </p:txBody>
+      </p:sp>
+      <p:sp>
+        <p:nvSpPr>
+          <p:cNvPr id="8" name="Rounded Rectangle 7"/>
           <p:cNvSpPr/>
           <p:nvPr/>
         </p:nvSpPr>
         <p:spPr>
           <a:xfrm>
-            <a:off x="6196431" y="1856232"/>
-            <a:ext cx="5428335" cy="2331720"/>
+            <a:off x="566928" y="3467607"/>
+            <a:ext cx="11057839" cy="2040128"/>
           </a:xfrm>
           <a:prstGeom prst="roundRect">
             <a:avLst>
-              <a:gd name="adj" fmla="val 6274"/>
-            </a:avLst>
-          </a:prstGeom>
-          <a:solidFill>
-            <a:srgbClr val="E6F5EE"/>
-          </a:solidFill>
-          <a:ln w="12700">
-            <a:solidFill>
-              <a:srgbClr val="0A8F5B"/>
-            </a:solidFill>
-          </a:ln>
-          <a:effectLst/>
-        </p:spPr>
-        <p:style>
-          <a:lnRef idx="1">
-            <a:schemeClr val="accent1"/>
-          </a:lnRef>
-          <a:fillRef idx="3">
-            <a:schemeClr val="accent1"/>
-          </a:fillRef>
-          <a:effectRef idx="2">
-            <a:schemeClr val="accent1"/>
-          </a:effectRef>
-          <a:fontRef idx="minor">
-            <a:schemeClr val="lt1"/>
-          </a:fontRef>
-        </p:style>
-        <p:txBody>
-          <a:bodyPr rtlCol="0" anchor="ctr"/>
-          <a:lstStyle/>
-          <a:p/>
-        </p:txBody>
-      </p:sp>
-      <p:sp>
-        <p:nvSpPr>
-          <p:cNvPr id="11" name="TextBox 10"/>
-          <p:cNvSpPr txBox="1"/>
-          <p:nvPr/>
-        </p:nvSpPr>
-        <p:spPr>
-          <a:xfrm>
-            <a:off x="6562191" y="2130552"/>
-            <a:ext cx="4696815" cy="274320"/>
-          </a:xfrm>
-          <a:prstGeom prst="rect">
-            <a:avLst/>
-          </a:prstGeom>
-          <a:noFill/>
-        </p:spPr>
-        <p:txBody>
-          <a:bodyPr wrap="square" lIns="0" rIns="0" tIns="0" bIns="0" anchor="t">
-            <a:spAutoFit/>
-          </a:bodyPr>
-          <a:lstStyle/>
-          <a:p>
-            <a:pPr algn="l">
-              <a:lnSpc>
-                <a:spcPct val="135000"/>
-              </a:lnSpc>
-            </a:pPr>
-            <a:r>
-              <a:rPr sz="1300" b="1" i="0" spc="156">
-                <a:solidFill>
-                  <a:srgbClr val="07734A"/>
-                </a:solidFill>
-                <a:latin typeface="Verdana"/>
-              </a:rPr>
-              <a:t>IL FAUT DIRE PLUTÔT</a:t>
-            </a:r>
-          </a:p>
-        </p:txBody>
-      </p:sp>
-      <p:sp>
-        <p:nvSpPr>
-          <p:cNvPr id="12" name="TextBox 11"/>
-          <p:cNvSpPr txBox="1"/>
-          <p:nvPr/>
-        </p:nvSpPr>
-        <p:spPr>
-          <a:xfrm>
-            <a:off x="6562191" y="2569464"/>
-            <a:ext cx="4696815" cy="1417320"/>
-          </a:xfrm>
-          <a:prstGeom prst="rect">
-            <a:avLst/>
-          </a:prstGeom>
-          <a:noFill/>
-        </p:spPr>
-        <p:txBody>
-          <a:bodyPr wrap="square" lIns="0" rIns="0" tIns="0" bIns="0" anchor="t">
-            <a:spAutoFit/>
-          </a:bodyPr>
-          <a:lstStyle/>
-          <a:p>
-            <a:pPr algn="l">
-              <a:lnSpc>
-                <a:spcPct val="130000"/>
-              </a:lnSpc>
-            </a:pPr>
-            <a:r>
-              <a:rPr sz="2500" b="1" i="0">
-                <a:solidFill>
-                  <a:srgbClr val="17181A"/>
-                </a:solidFill>
-                <a:latin typeface="Verdana"/>
-              </a:rPr>
-              <a:t>« Il a interdiction de donner une réponse. »</a:t>
-            </a:r>
-          </a:p>
-        </p:txBody>
-      </p:sp>
-      <p:sp>
-        <p:nvSpPr>
-          <p:cNvPr id="13" name="Rounded Rectangle 12"/>
-          <p:cNvSpPr/>
-          <p:nvPr/>
-        </p:nvSpPr>
-        <p:spPr>
-          <a:xfrm>
-            <a:off x="566928" y="4462272"/>
-            <a:ext cx="11057839" cy="1618487"/>
-          </a:xfrm>
-          <a:prstGeom prst="roundRect">
-            <a:avLst>
-              <a:gd name="adj" fmla="val 9039"/>
+              <a:gd name="adj" fmla="val 7171"/>
             </a:avLst>
           </a:prstGeom>
           <a:solidFill>
@@ -6317,14 +6186,14 @@
       </p:sp>
       <p:sp>
         <p:nvSpPr>
-          <p:cNvPr id="14" name="TextBox 13"/>
-          <p:cNvSpPr txBox="1"/>
-          <p:nvPr/>
-        </p:nvSpPr>
-        <p:spPr>
-          <a:xfrm>
-            <a:off x="969264" y="4736592"/>
-            <a:ext cx="10234879" cy="1150620"/>
+          <p:cNvPr id="9" name="TextBox 8"/>
+          <p:cNvSpPr txBox="1"/>
+          <p:nvPr/>
+        </p:nvSpPr>
+        <p:spPr>
+          <a:xfrm>
+            <a:off x="969264" y="3741927"/>
+            <a:ext cx="10234879" cy="1582928"/>
           </a:xfrm>
           <a:prstGeom prst="rect">
             <a:avLst/>
@@ -6349,7 +6218,7 @@
                 </a:solidFill>
                 <a:latin typeface="Verdana"/>
               </a:rPr>
-              <a:t>Il cite la phrase du dialogue où se trouve l'information, puis repose une question plus facile. La traduction s'ajoute sous le français et ne le remplace jamais ; « simplifier » reformule en français, il ne traduit pas.</a:t>
+              <a:t>La section « Je retiens des mots » d'un module n'enregistre rien : elle fait travailler. C'est l'atelier de cartes mémoire, en répétition espacée, qui fait monter un mot d'une boîte à l'autre — et l'élève y **écrit** le mot, il ne le reconnaît pas dans une liste.</a:t>
             </a:r>
           </a:p>
         </p:txBody>
@@ -6526,33 +6395,72 @@
                 </a:solidFill>
                 <a:latin typeface="Verdana"/>
               </a:rPr>
-              <a:t>QUI DÉCIDE</a:t>
-            </a:r>
-          </a:p>
-        </p:txBody>
-      </p:sp>
-      <p:sp>
-        <p:nvSpPr>
-          <p:cNvPr id="6" name="Rounded Rectangle 5"/>
+              <a:t>LA QUESTION QUI VIENT TOUJOURS</a:t>
+            </a:r>
+          </a:p>
+        </p:txBody>
+      </p:sp>
+      <p:sp>
+        <p:nvSpPr>
+          <p:cNvPr id="6" name="TextBox 5"/>
+          <p:cNvSpPr txBox="1"/>
+          <p:nvPr/>
+        </p:nvSpPr>
+        <p:spPr>
+          <a:xfrm>
+            <a:off x="566928" y="749808"/>
+            <a:ext cx="11057839" cy="877824"/>
+          </a:xfrm>
+          <a:prstGeom prst="rect">
+            <a:avLst/>
+          </a:prstGeom>
+          <a:noFill/>
+        </p:spPr>
+        <p:txBody>
+          <a:bodyPr wrap="square" lIns="0" rIns="0" tIns="0" bIns="0" anchor="t">
+            <a:spAutoFit/>
+          </a:bodyPr>
+          <a:lstStyle/>
+          <a:p>
+            <a:pPr algn="l">
+              <a:lnSpc>
+                <a:spcPct val="115000"/>
+              </a:lnSpc>
+            </a:pPr>
+            <a:r>
+              <a:rPr sz="3400" b="1" i="0">
+                <a:solidFill>
+                  <a:srgbClr val="17181A"/>
+                </a:solidFill>
+                <a:latin typeface="Verdana"/>
+              </a:rPr>
+              <a:t>Le piège le plus fréquent</a:t>
+            </a:r>
+          </a:p>
+        </p:txBody>
+      </p:sp>
+      <p:sp>
+        <p:nvSpPr>
+          <p:cNvPr id="7" name="Rounded Rectangle 6"/>
           <p:cNvSpPr/>
           <p:nvPr/>
         </p:nvSpPr>
         <p:spPr>
           <a:xfrm>
-            <a:off x="566928" y="1225296"/>
-            <a:ext cx="11057839" cy="1967991"/>
+            <a:off x="566928" y="1856232"/>
+            <a:ext cx="5428335" cy="2331720"/>
           </a:xfrm>
           <a:prstGeom prst="roundRect">
             <a:avLst>
-              <a:gd name="adj" fmla="val 7434"/>
+              <a:gd name="adj" fmla="val 6274"/>
             </a:avLst>
           </a:prstGeom>
           <a:solidFill>
-            <a:srgbClr val="FCE9F0"/>
+            <a:srgbClr val="FFF6F5"/>
           </a:solidFill>
           <a:ln w="12700">
             <a:solidFill>
-              <a:srgbClr val="EAEAE8"/>
+              <a:srgbClr val="DC2626"/>
             </a:solidFill>
           </a:ln>
           <a:effectLst/>
@@ -6579,14 +6487,14 @@
       </p:sp>
       <p:sp>
         <p:nvSpPr>
-          <p:cNvPr id="7" name="TextBox 6"/>
-          <p:cNvSpPr txBox="1"/>
-          <p:nvPr/>
-        </p:nvSpPr>
-        <p:spPr>
-          <a:xfrm>
-            <a:off x="1298448" y="1682496"/>
-            <a:ext cx="9594799" cy="1145032"/>
+          <p:cNvPr id="8" name="TextBox 7"/>
+          <p:cNvSpPr txBox="1"/>
+          <p:nvPr/>
+        </p:nvSpPr>
+        <p:spPr>
+          <a:xfrm>
+            <a:off x="932688" y="2130552"/>
+            <a:ext cx="4696815" cy="274320"/>
           </a:xfrm>
           <a:prstGeom prst="rect">
             <a:avLst/>
@@ -6601,35 +6509,198 @@
           <a:p>
             <a:pPr algn="l">
               <a:lnSpc>
-                <a:spcPct val="122000"/>
-              </a:lnSpc>
-            </a:pPr>
-            <a:r>
-              <a:rPr sz="3400" b="1" i="0">
+                <a:spcPct val="135000"/>
+              </a:lnSpc>
+            </a:pPr>
+            <a:r>
+              <a:rPr sz="1300" b="1" i="0" spc="156">
+                <a:solidFill>
+                  <a:srgbClr val="B91C1C"/>
+                </a:solidFill>
+                <a:latin typeface="Verdana"/>
+              </a:rPr>
+              <a:t>ON ENTEND SOUVENT</a:t>
+            </a:r>
+          </a:p>
+        </p:txBody>
+      </p:sp>
+      <p:sp>
+        <p:nvSpPr>
+          <p:cNvPr id="9" name="TextBox 8"/>
+          <p:cNvSpPr txBox="1"/>
+          <p:nvPr/>
+        </p:nvSpPr>
+        <p:spPr>
+          <a:xfrm>
+            <a:off x="932688" y="2569464"/>
+            <a:ext cx="4696815" cy="1417320"/>
+          </a:xfrm>
+          <a:prstGeom prst="rect">
+            <a:avLst/>
+          </a:prstGeom>
+          <a:noFill/>
+        </p:spPr>
+        <p:txBody>
+          <a:bodyPr wrap="square" lIns="0" rIns="0" tIns="0" bIns="0" anchor="t">
+            <a:spAutoFit/>
+          </a:bodyPr>
+          <a:lstStyle/>
+          <a:p>
+            <a:pPr algn="l">
+              <a:lnSpc>
+                <a:spcPct val="130000"/>
+              </a:lnSpc>
+            </a:pPr>
+            <a:r>
+              <a:rPr sz="2500" b="1" i="0">
                 <a:solidFill>
                   <a:srgbClr val="17181A"/>
                 </a:solidFill>
                 <a:latin typeface="Verdana"/>
               </a:rPr>
-              <a:t>Aucun parcours n'est suggéré automatiquement à un élève.</a:t>
-            </a:r>
-          </a:p>
-        </p:txBody>
-      </p:sp>
-      <p:sp>
-        <p:nvSpPr>
-          <p:cNvPr id="8" name="Rounded Rectangle 7"/>
+              <a:t>« Votre assistant va faire les exercices à leur place. »</a:t>
+            </a:r>
+          </a:p>
+        </p:txBody>
+      </p:sp>
+      <p:sp>
+        <p:nvSpPr>
+          <p:cNvPr id="10" name="Rounded Rectangle 9"/>
           <p:cNvSpPr/>
           <p:nvPr/>
         </p:nvSpPr>
         <p:spPr>
           <a:xfrm>
-            <a:off x="566928" y="3467607"/>
-            <a:ext cx="11057839" cy="1671827"/>
+            <a:off x="6196431" y="1856232"/>
+            <a:ext cx="5428335" cy="2331720"/>
           </a:xfrm>
           <a:prstGeom prst="roundRect">
             <a:avLst>
-              <a:gd name="adj" fmla="val 8751"/>
+              <a:gd name="adj" fmla="val 6274"/>
+            </a:avLst>
+          </a:prstGeom>
+          <a:solidFill>
+            <a:srgbClr val="E6F5EE"/>
+          </a:solidFill>
+          <a:ln w="12700">
+            <a:solidFill>
+              <a:srgbClr val="0A8F5B"/>
+            </a:solidFill>
+          </a:ln>
+          <a:effectLst/>
+        </p:spPr>
+        <p:style>
+          <a:lnRef idx="1">
+            <a:schemeClr val="accent1"/>
+          </a:lnRef>
+          <a:fillRef idx="3">
+            <a:schemeClr val="accent1"/>
+          </a:fillRef>
+          <a:effectRef idx="2">
+            <a:schemeClr val="accent1"/>
+          </a:effectRef>
+          <a:fontRef idx="minor">
+            <a:schemeClr val="lt1"/>
+          </a:fontRef>
+        </p:style>
+        <p:txBody>
+          <a:bodyPr rtlCol="0" anchor="ctr"/>
+          <a:lstStyle/>
+          <a:p/>
+        </p:txBody>
+      </p:sp>
+      <p:sp>
+        <p:nvSpPr>
+          <p:cNvPr id="11" name="TextBox 10"/>
+          <p:cNvSpPr txBox="1"/>
+          <p:nvPr/>
+        </p:nvSpPr>
+        <p:spPr>
+          <a:xfrm>
+            <a:off x="6562191" y="2130552"/>
+            <a:ext cx="4696815" cy="274320"/>
+          </a:xfrm>
+          <a:prstGeom prst="rect">
+            <a:avLst/>
+          </a:prstGeom>
+          <a:noFill/>
+        </p:spPr>
+        <p:txBody>
+          <a:bodyPr wrap="square" lIns="0" rIns="0" tIns="0" bIns="0" anchor="t">
+            <a:spAutoFit/>
+          </a:bodyPr>
+          <a:lstStyle/>
+          <a:p>
+            <a:pPr algn="l">
+              <a:lnSpc>
+                <a:spcPct val="135000"/>
+              </a:lnSpc>
+            </a:pPr>
+            <a:r>
+              <a:rPr sz="1300" b="1" i="0" spc="156">
+                <a:solidFill>
+                  <a:srgbClr val="07734A"/>
+                </a:solidFill>
+                <a:latin typeface="Verdana"/>
+              </a:rPr>
+              <a:t>IL FAUT DIRE PLUTÔT</a:t>
+            </a:r>
+          </a:p>
+        </p:txBody>
+      </p:sp>
+      <p:sp>
+        <p:nvSpPr>
+          <p:cNvPr id="12" name="TextBox 11"/>
+          <p:cNvSpPr txBox="1"/>
+          <p:nvPr/>
+        </p:nvSpPr>
+        <p:spPr>
+          <a:xfrm>
+            <a:off x="6562191" y="2569464"/>
+            <a:ext cx="4696815" cy="1417320"/>
+          </a:xfrm>
+          <a:prstGeom prst="rect">
+            <a:avLst/>
+          </a:prstGeom>
+          <a:noFill/>
+        </p:spPr>
+        <p:txBody>
+          <a:bodyPr wrap="square" lIns="0" rIns="0" tIns="0" bIns="0" anchor="t">
+            <a:spAutoFit/>
+          </a:bodyPr>
+          <a:lstStyle/>
+          <a:p>
+            <a:pPr algn="l">
+              <a:lnSpc>
+                <a:spcPct val="130000"/>
+              </a:lnSpc>
+            </a:pPr>
+            <a:r>
+              <a:rPr sz="2500" b="1" i="0">
+                <a:solidFill>
+                  <a:srgbClr val="17181A"/>
+                </a:solidFill>
+                <a:latin typeface="Verdana"/>
+              </a:rPr>
+              <a:t>« Il a interdiction de donner une réponse. »</a:t>
+            </a:r>
+          </a:p>
+        </p:txBody>
+      </p:sp>
+      <p:sp>
+        <p:nvSpPr>
+          <p:cNvPr id="13" name="Rounded Rectangle 12"/>
+          <p:cNvSpPr/>
+          <p:nvPr/>
+        </p:nvSpPr>
+        <p:spPr>
+          <a:xfrm>
+            <a:off x="566928" y="4462272"/>
+            <a:ext cx="11057839" cy="1618487"/>
+          </a:xfrm>
+          <a:prstGeom prst="roundRect">
+            <a:avLst>
+              <a:gd name="adj" fmla="val 9039"/>
             </a:avLst>
           </a:prstGeom>
           <a:solidFill>
@@ -6664,14 +6735,14 @@
       </p:sp>
       <p:sp>
         <p:nvSpPr>
-          <p:cNvPr id="9" name="TextBox 8"/>
-          <p:cNvSpPr txBox="1"/>
-          <p:nvPr/>
-        </p:nvSpPr>
-        <p:spPr>
-          <a:xfrm>
-            <a:off x="969264" y="3741927"/>
-            <a:ext cx="10234879" cy="1214627"/>
+          <p:cNvPr id="14" name="TextBox 13"/>
+          <p:cNvSpPr txBox="1"/>
+          <p:nvPr/>
+        </p:nvSpPr>
+        <p:spPr>
+          <a:xfrm>
+            <a:off x="969264" y="4736592"/>
+            <a:ext cx="10234879" cy="1150620"/>
           </a:xfrm>
           <a:prstGeom prst="rect">
             <a:avLst/>
@@ -6696,7 +6767,7 @@
                 </a:solidFill>
                 <a:latin typeface="Verdana"/>
               </a:rPr>
-              <a:t>Le portail dit ce qu'un élève a fait et où il s'est trompé. Il ne conclut rien et ne propose rien. C'est l'enseignant qui envoie une mini-leçon de dix minutes à qui en a besoin — un choix, pas une étape transitoire vers l'automatisation.</a:t>
+              <a:t>Il cite la phrase du dialogue où se trouve l'information, puis repose une question plus facile. La traduction s'ajoute sous le français et ne le remplace jamais ; « simplifier » reformule en français, il ne traduit pas.</a:t>
             </a:r>
           </a:p>
         </p:txBody>
@@ -6873,64 +6944,110 @@
                 </a:solidFill>
                 <a:latin typeface="Verdana"/>
               </a:rPr>
-              <a:t>CE QU'ON N'A PAS RETIRÉ</a:t>
-            </a:r>
-          </a:p>
-        </p:txBody>
-      </p:sp>
-      <p:sp>
-        <p:nvSpPr>
-          <p:cNvPr id="6" name="TextBox 5"/>
-          <p:cNvSpPr txBox="1"/>
-          <p:nvPr/>
-        </p:nvSpPr>
-        <p:spPr>
-          <a:xfrm>
-            <a:off x="566928" y="749808"/>
-            <a:ext cx="11057839" cy="877824"/>
-          </a:xfrm>
-          <a:prstGeom prst="rect">
-            <a:avLst/>
-          </a:prstGeom>
-          <a:noFill/>
-        </p:spPr>
-        <p:txBody>
-          <a:bodyPr wrap="square" lIns="0" rIns="0" tIns="0" bIns="0" anchor="t">
-            <a:spAutoFit/>
-          </a:bodyPr>
-          <a:lstStyle/>
-          <a:p>
-            <a:pPr algn="l">
-              <a:lnSpc>
-                <a:spcPct val="115000"/>
-              </a:lnSpc>
-            </a:pPr>
-            <a:r>
-              <a:rPr sz="3400" b="1" i="0">
-                <a:solidFill>
-                  <a:srgbClr val="17181A"/>
-                </a:solidFill>
-                <a:latin typeface="Verdana"/>
-              </a:rPr>
-              <a:t>Quatre choses qui restent, et c'est délibéré</a:t>
-            </a:r>
-          </a:p>
-        </p:txBody>
-      </p:sp>
-      <p:sp>
-        <p:nvSpPr>
-          <p:cNvPr id="7" name="Rounded Rectangle 6"/>
+              <a:t>QUI DÉCIDE</a:t>
+            </a:r>
+          </a:p>
+        </p:txBody>
+      </p:sp>
+      <p:sp>
+        <p:nvSpPr>
+          <p:cNvPr id="6" name="Rounded Rectangle 5"/>
           <p:cNvSpPr/>
           <p:nvPr/>
         </p:nvSpPr>
         <p:spPr>
           <a:xfrm>
-            <a:off x="566928" y="1810512"/>
-            <a:ext cx="5446623" cy="2052828"/>
+            <a:off x="566928" y="1225296"/>
+            <a:ext cx="11057839" cy="1967991"/>
           </a:xfrm>
           <a:prstGeom prst="roundRect">
             <a:avLst>
-              <a:gd name="adj" fmla="val 7126"/>
+              <a:gd name="adj" fmla="val 7434"/>
+            </a:avLst>
+          </a:prstGeom>
+          <a:solidFill>
+            <a:srgbClr val="FCE9F0"/>
+          </a:solidFill>
+          <a:ln w="12700">
+            <a:solidFill>
+              <a:srgbClr val="EAEAE8"/>
+            </a:solidFill>
+          </a:ln>
+          <a:effectLst/>
+        </p:spPr>
+        <p:style>
+          <a:lnRef idx="1">
+            <a:schemeClr val="accent1"/>
+          </a:lnRef>
+          <a:fillRef idx="3">
+            <a:schemeClr val="accent1"/>
+          </a:fillRef>
+          <a:effectRef idx="2">
+            <a:schemeClr val="accent1"/>
+          </a:effectRef>
+          <a:fontRef idx="minor">
+            <a:schemeClr val="lt1"/>
+          </a:fontRef>
+        </p:style>
+        <p:txBody>
+          <a:bodyPr rtlCol="0" anchor="ctr"/>
+          <a:lstStyle/>
+          <a:p/>
+        </p:txBody>
+      </p:sp>
+      <p:sp>
+        <p:nvSpPr>
+          <p:cNvPr id="7" name="TextBox 6"/>
+          <p:cNvSpPr txBox="1"/>
+          <p:nvPr/>
+        </p:nvSpPr>
+        <p:spPr>
+          <a:xfrm>
+            <a:off x="1298448" y="1682496"/>
+            <a:ext cx="9594799" cy="1145032"/>
+          </a:xfrm>
+          <a:prstGeom prst="rect">
+            <a:avLst/>
+          </a:prstGeom>
+          <a:noFill/>
+        </p:spPr>
+        <p:txBody>
+          <a:bodyPr wrap="square" lIns="0" rIns="0" tIns="0" bIns="0" anchor="t">
+            <a:spAutoFit/>
+          </a:bodyPr>
+          <a:lstStyle/>
+          <a:p>
+            <a:pPr algn="l">
+              <a:lnSpc>
+                <a:spcPct val="122000"/>
+              </a:lnSpc>
+            </a:pPr>
+            <a:r>
+              <a:rPr sz="3400" b="1" i="0">
+                <a:solidFill>
+                  <a:srgbClr val="17181A"/>
+                </a:solidFill>
+                <a:latin typeface="Verdana"/>
+              </a:rPr>
+              <a:t>Aucun parcours n'est suggéré automatiquement à un élève.</a:t>
+            </a:r>
+          </a:p>
+        </p:txBody>
+      </p:sp>
+      <p:sp>
+        <p:nvSpPr>
+          <p:cNvPr id="8" name="Rounded Rectangle 7"/>
+          <p:cNvSpPr/>
+          <p:nvPr/>
+        </p:nvSpPr>
+        <p:spPr>
+          <a:xfrm>
+            <a:off x="566928" y="3467607"/>
+            <a:ext cx="11057839" cy="1671827"/>
+          </a:xfrm>
+          <a:prstGeom prst="roundRect">
+            <a:avLst>
+              <a:gd name="adj" fmla="val 8751"/>
             </a:avLst>
           </a:prstGeom>
           <a:solidFill>
@@ -6965,14 +7082,14 @@
       </p:sp>
       <p:sp>
         <p:nvSpPr>
-          <p:cNvPr id="8" name="TextBox 7"/>
-          <p:cNvSpPr txBox="1"/>
-          <p:nvPr/>
-        </p:nvSpPr>
-        <p:spPr>
-          <a:xfrm>
-            <a:off x="886968" y="2084831"/>
-            <a:ext cx="4806543" cy="387096"/>
+          <p:cNvPr id="9" name="TextBox 8"/>
+          <p:cNvSpPr txBox="1"/>
+          <p:nvPr/>
+        </p:nvSpPr>
+        <p:spPr>
+          <a:xfrm>
+            <a:off x="969264" y="3741927"/>
+            <a:ext cx="10234879" cy="1214627"/>
           </a:xfrm>
           <a:prstGeom prst="rect">
             <a:avLst/>
@@ -6987,428 +7104,17 @@
           <a:p>
             <a:pPr algn="l">
               <a:lnSpc>
-                <a:spcPct val="118000"/>
-              </a:lnSpc>
-            </a:pPr>
-            <a:r>
-              <a:rPr sz="2400" b="1" i="0">
-                <a:solidFill>
-                  <a:srgbClr val="A5335F"/>
-                </a:solidFill>
-                <a:latin typeface="Verdana"/>
-              </a:rPr>
-              <a:t>L'enseignant</a:t>
-            </a:r>
-          </a:p>
-        </p:txBody>
-      </p:sp>
-      <p:sp>
-        <p:nvSpPr>
-          <p:cNvPr id="9" name="TextBox 8"/>
-          <p:cNvSpPr txBox="1"/>
-          <p:nvPr/>
-        </p:nvSpPr>
-        <p:spPr>
-          <a:xfrm>
-            <a:off x="886968" y="2499360"/>
-            <a:ext cx="4806543" cy="1089660"/>
-          </a:xfrm>
-          <a:prstGeom prst="rect">
-            <a:avLst/>
-          </a:prstGeom>
-          <a:noFill/>
-        </p:spPr>
-        <p:txBody>
-          <a:bodyPr wrap="square" lIns="0" rIns="0" tIns="0" bIns="0" anchor="t">
-            <a:spAutoFit/>
-          </a:bodyPr>
-          <a:lstStyle/>
-          <a:p>
-            <a:pPr algn="l">
-              <a:lnSpc>
-                <a:spcPct val="142000"/>
-              </a:lnSpc>
-            </a:pPr>
-            <a:r>
-              <a:rPr sz="1800" b="0" i="0">
-                <a:solidFill>
-                  <a:srgbClr val="3A3D40"/>
-                </a:solidFill>
-                <a:latin typeface="Verdana"/>
-              </a:rPr>
-              <a:t>Rien ne s'ouvre tout seul à un élève. C'est l'enseignant qui date un module, choisit la séance, lit les productions.</a:t>
-            </a:r>
-          </a:p>
-        </p:txBody>
-      </p:sp>
-      <p:sp>
-        <p:nvSpPr>
-          <p:cNvPr id="10" name="Rounded Rectangle 9"/>
-          <p:cNvSpPr/>
-          <p:nvPr/>
-        </p:nvSpPr>
-        <p:spPr>
-          <a:xfrm>
-            <a:off x="6178143" y="1810512"/>
-            <a:ext cx="5446623" cy="2052828"/>
-          </a:xfrm>
-          <a:prstGeom prst="roundRect">
-            <a:avLst>
-              <a:gd name="adj" fmla="val 7126"/>
-            </a:avLst>
-          </a:prstGeom>
-          <a:solidFill>
-            <a:srgbClr val="FFFFFF"/>
-          </a:solidFill>
-          <a:ln w="12700">
-            <a:solidFill>
-              <a:srgbClr val="EAEAE8"/>
-            </a:solidFill>
-          </a:ln>
-          <a:effectLst/>
-        </p:spPr>
-        <p:style>
-          <a:lnRef idx="1">
-            <a:schemeClr val="accent1"/>
-          </a:lnRef>
-          <a:fillRef idx="3">
-            <a:schemeClr val="accent1"/>
-          </a:fillRef>
-          <a:effectRef idx="2">
-            <a:schemeClr val="accent1"/>
-          </a:effectRef>
-          <a:fontRef idx="minor">
-            <a:schemeClr val="lt1"/>
-          </a:fontRef>
-        </p:style>
-        <p:txBody>
-          <a:bodyPr rtlCol="0" anchor="ctr"/>
-          <a:lstStyle/>
-          <a:p/>
-        </p:txBody>
-      </p:sp>
-      <p:sp>
-        <p:nvSpPr>
-          <p:cNvPr id="11" name="TextBox 10"/>
-          <p:cNvSpPr txBox="1"/>
-          <p:nvPr/>
-        </p:nvSpPr>
-        <p:spPr>
-          <a:xfrm>
-            <a:off x="6498183" y="2084831"/>
-            <a:ext cx="4806543" cy="387096"/>
-          </a:xfrm>
-          <a:prstGeom prst="rect">
-            <a:avLst/>
-          </a:prstGeom>
-          <a:noFill/>
-        </p:spPr>
-        <p:txBody>
-          <a:bodyPr wrap="square" lIns="0" rIns="0" tIns="0" bIns="0" anchor="t">
-            <a:spAutoFit/>
-          </a:bodyPr>
-          <a:lstStyle/>
-          <a:p>
-            <a:pPr algn="l">
-              <a:lnSpc>
-                <a:spcPct val="118000"/>
-              </a:lnSpc>
-            </a:pPr>
-            <a:r>
-              <a:rPr sz="2400" b="1" i="0">
-                <a:solidFill>
-                  <a:srgbClr val="A5335F"/>
-                </a:solidFill>
-                <a:latin typeface="Verdana"/>
-              </a:rPr>
-              <a:t>Le papier</a:t>
-            </a:r>
-          </a:p>
-        </p:txBody>
-      </p:sp>
-      <p:sp>
-        <p:nvSpPr>
-          <p:cNvPr id="12" name="TextBox 11"/>
-          <p:cNvSpPr txBox="1"/>
-          <p:nvPr/>
-        </p:nvSpPr>
-        <p:spPr>
-          <a:xfrm>
-            <a:off x="6498183" y="2499360"/>
-            <a:ext cx="4806543" cy="1089660"/>
-          </a:xfrm>
-          <a:prstGeom prst="rect">
-            <a:avLst/>
-          </a:prstGeom>
-          <a:noFill/>
-        </p:spPr>
-        <p:txBody>
-          <a:bodyPr wrap="square" lIns="0" rIns="0" tIns="0" bIns="0" anchor="t">
-            <a:spAutoFit/>
-          </a:bodyPr>
-          <a:lstStyle/>
-          <a:p>
-            <a:pPr algn="l">
-              <a:lnSpc>
-                <a:spcPct val="142000"/>
-              </a:lnSpc>
-            </a:pPr>
-            <a:r>
-              <a:rPr sz="1800" b="0" i="0">
-                <a:solidFill>
-                  <a:srgbClr val="3A3D40"/>
-                </a:solidFill>
-                <a:latin typeface="Verdana"/>
-              </a:rPr>
-              <a:t>1 264 fiches imprimables, noir et blanc. Un élève sans appareil fait la séance quand même.</a:t>
-            </a:r>
-          </a:p>
-        </p:txBody>
-      </p:sp>
-      <p:sp>
-        <p:nvSpPr>
-          <p:cNvPr id="13" name="Rounded Rectangle 12"/>
-          <p:cNvSpPr/>
-          <p:nvPr/>
-        </p:nvSpPr>
-        <p:spPr>
-          <a:xfrm>
-            <a:off x="566928" y="4027932"/>
-            <a:ext cx="5446623" cy="2052828"/>
-          </a:xfrm>
-          <a:prstGeom prst="roundRect">
-            <a:avLst>
-              <a:gd name="adj" fmla="val 7126"/>
-            </a:avLst>
-          </a:prstGeom>
-          <a:solidFill>
-            <a:srgbClr val="FFFFFF"/>
-          </a:solidFill>
-          <a:ln w="12700">
-            <a:solidFill>
-              <a:srgbClr val="EAEAE8"/>
-            </a:solidFill>
-          </a:ln>
-          <a:effectLst/>
-        </p:spPr>
-        <p:style>
-          <a:lnRef idx="1">
-            <a:schemeClr val="accent1"/>
-          </a:lnRef>
-          <a:fillRef idx="3">
-            <a:schemeClr val="accent1"/>
-          </a:fillRef>
-          <a:effectRef idx="2">
-            <a:schemeClr val="accent1"/>
-          </a:effectRef>
-          <a:fontRef idx="minor">
-            <a:schemeClr val="lt1"/>
-          </a:fontRef>
-        </p:style>
-        <p:txBody>
-          <a:bodyPr rtlCol="0" anchor="ctr"/>
-          <a:lstStyle/>
-          <a:p/>
-        </p:txBody>
-      </p:sp>
-      <p:sp>
-        <p:nvSpPr>
-          <p:cNvPr id="14" name="TextBox 13"/>
-          <p:cNvSpPr txBox="1"/>
-          <p:nvPr/>
-        </p:nvSpPr>
-        <p:spPr>
-          <a:xfrm>
-            <a:off x="886968" y="4302252"/>
-            <a:ext cx="4806543" cy="387096"/>
-          </a:xfrm>
-          <a:prstGeom prst="rect">
-            <a:avLst/>
-          </a:prstGeom>
-          <a:noFill/>
-        </p:spPr>
-        <p:txBody>
-          <a:bodyPr wrap="square" lIns="0" rIns="0" tIns="0" bIns="0" anchor="t">
-            <a:spAutoFit/>
-          </a:bodyPr>
-          <a:lstStyle/>
-          <a:p>
-            <a:pPr algn="l">
-              <a:lnSpc>
-                <a:spcPct val="118000"/>
-              </a:lnSpc>
-            </a:pPr>
-            <a:r>
-              <a:rPr sz="2400" b="1" i="0">
-                <a:solidFill>
-                  <a:srgbClr val="A5335F"/>
-                </a:solidFill>
-                <a:latin typeface="Verdana"/>
-              </a:rPr>
-              <a:t>La classe</a:t>
-            </a:r>
-          </a:p>
-        </p:txBody>
-      </p:sp>
-      <p:sp>
-        <p:nvSpPr>
-          <p:cNvPr id="15" name="TextBox 14"/>
-          <p:cNvSpPr txBox="1"/>
-          <p:nvPr/>
-        </p:nvSpPr>
-        <p:spPr>
-          <a:xfrm>
-            <a:off x="886968" y="4716780"/>
-            <a:ext cx="4806543" cy="1089660"/>
-          </a:xfrm>
-          <a:prstGeom prst="rect">
-            <a:avLst/>
-          </a:prstGeom>
-          <a:noFill/>
-        </p:spPr>
-        <p:txBody>
-          <a:bodyPr wrap="square" lIns="0" rIns="0" tIns="0" bIns="0" anchor="t">
-            <a:spAutoFit/>
-          </a:bodyPr>
-          <a:lstStyle/>
-          <a:p>
-            <a:pPr algn="l">
-              <a:lnSpc>
-                <a:spcPct val="142000"/>
-              </a:lnSpc>
-            </a:pPr>
-            <a:r>
-              <a:rPr sz="1800" b="0" i="0">
-                <a:solidFill>
-                  <a:srgbClr val="3A3D40"/>
-                </a:solidFill>
-                <a:latin typeface="Verdana"/>
-              </a:rPr>
-              <a:t>Le jeu de rôle a une moitié qui se joue à deux, en salle. Elle ne disparaît pas quand l'assistant est fermé.</a:t>
-            </a:r>
-          </a:p>
-        </p:txBody>
-      </p:sp>
-      <p:sp>
-        <p:nvSpPr>
-          <p:cNvPr id="16" name="Rounded Rectangle 15"/>
-          <p:cNvSpPr/>
-          <p:nvPr/>
-        </p:nvSpPr>
-        <p:spPr>
-          <a:xfrm>
-            <a:off x="6178143" y="4027932"/>
-            <a:ext cx="5446623" cy="2052828"/>
-          </a:xfrm>
-          <a:prstGeom prst="roundRect">
-            <a:avLst>
-              <a:gd name="adj" fmla="val 7126"/>
-            </a:avLst>
-          </a:prstGeom>
-          <a:solidFill>
-            <a:srgbClr val="FFFFFF"/>
-          </a:solidFill>
-          <a:ln w="12700">
-            <a:solidFill>
-              <a:srgbClr val="EAEAE8"/>
-            </a:solidFill>
-          </a:ln>
-          <a:effectLst/>
-        </p:spPr>
-        <p:style>
-          <a:lnRef idx="1">
-            <a:schemeClr val="accent1"/>
-          </a:lnRef>
-          <a:fillRef idx="3">
-            <a:schemeClr val="accent1"/>
-          </a:fillRef>
-          <a:effectRef idx="2">
-            <a:schemeClr val="accent1"/>
-          </a:effectRef>
-          <a:fontRef idx="minor">
-            <a:schemeClr val="lt1"/>
-          </a:fontRef>
-        </p:style>
-        <p:txBody>
-          <a:bodyPr rtlCol="0" anchor="ctr"/>
-          <a:lstStyle/>
-          <a:p/>
-        </p:txBody>
-      </p:sp>
-      <p:sp>
-        <p:nvSpPr>
-          <p:cNvPr id="17" name="TextBox 16"/>
-          <p:cNvSpPr txBox="1"/>
-          <p:nvPr/>
-        </p:nvSpPr>
-        <p:spPr>
-          <a:xfrm>
-            <a:off x="6498183" y="4302252"/>
-            <a:ext cx="4806543" cy="387096"/>
-          </a:xfrm>
-          <a:prstGeom prst="rect">
-            <a:avLst/>
-          </a:prstGeom>
-          <a:noFill/>
-        </p:spPr>
-        <p:txBody>
-          <a:bodyPr wrap="square" lIns="0" rIns="0" tIns="0" bIns="0" anchor="t">
-            <a:spAutoFit/>
-          </a:bodyPr>
-          <a:lstStyle/>
-          <a:p>
-            <a:pPr algn="l">
-              <a:lnSpc>
-                <a:spcPct val="118000"/>
-              </a:lnSpc>
-            </a:pPr>
-            <a:r>
-              <a:rPr sz="2400" b="1" i="0">
-                <a:solidFill>
-                  <a:srgbClr val="A5335F"/>
-                </a:solidFill>
-                <a:latin typeface="Verdana"/>
-              </a:rPr>
-              <a:t>Le droit de refuser</a:t>
-            </a:r>
-          </a:p>
-        </p:txBody>
-      </p:sp>
-      <p:sp>
-        <p:nvSpPr>
-          <p:cNvPr id="18" name="TextBox 17"/>
-          <p:cNvSpPr txBox="1"/>
-          <p:nvPr/>
-        </p:nvSpPr>
-        <p:spPr>
-          <a:xfrm>
-            <a:off x="6498183" y="4716780"/>
-            <a:ext cx="4806543" cy="1089660"/>
-          </a:xfrm>
-          <a:prstGeom prst="rect">
-            <a:avLst/>
-          </a:prstGeom>
-          <a:noFill/>
-        </p:spPr>
-        <p:txBody>
-          <a:bodyPr wrap="square" lIns="0" rIns="0" tIns="0" bIns="0" anchor="t">
-            <a:spAutoFit/>
-          </a:bodyPr>
-          <a:lstStyle/>
-          <a:p>
-            <a:pPr algn="l">
-              <a:lnSpc>
-                <a:spcPct val="142000"/>
-              </a:lnSpc>
-            </a:pPr>
-            <a:r>
-              <a:rPr sz="1800" b="0" i="0">
-                <a:solidFill>
-                  <a:srgbClr val="3A3D40"/>
-                </a:solidFill>
-                <a:latin typeface="Verdana"/>
-              </a:rPr>
-              <a:t>Un centre peut fermer l'assistant. Les 87 modules se replient : ce qui reste est un cours, pas une démo cassée.</a:t>
+                <a:spcPct val="145000"/>
+              </a:lnSpc>
+            </a:pPr>
+            <a:r>
+              <a:rPr sz="2000" b="0" i="0">
+                <a:solidFill>
+                  <a:srgbClr val="4B4F52"/>
+                </a:solidFill>
+                <a:latin typeface="Verdana"/>
+              </a:rPr>
+              <a:t>Le portail dit ce qu'un élève a fait et où il s'est trompé. Il ne conclut rien et ne propose rien. C'est l'enseignant qui envoie une mini-leçon de dix minutes à qui en a besoin — un choix, pas une étape transitoire vers l'automatisation.</a:t>
             </a:r>
           </a:p>
         </p:txBody>
@@ -7553,6 +7259,718 @@
       </p:sp>
       <p:sp>
         <p:nvSpPr>
+          <p:cNvPr id="5" name="TextBox 4"/>
+          <p:cNvSpPr txBox="1"/>
+          <p:nvPr/>
+        </p:nvSpPr>
+        <p:spPr>
+          <a:xfrm>
+            <a:off x="566928" y="420624"/>
+            <a:ext cx="11057839" cy="237744"/>
+          </a:xfrm>
+          <a:prstGeom prst="rect">
+            <a:avLst/>
+          </a:prstGeom>
+          <a:noFill/>
+        </p:spPr>
+        <p:txBody>
+          <a:bodyPr wrap="square" lIns="0" rIns="0" tIns="0" bIns="0" anchor="t">
+            <a:spAutoFit/>
+          </a:bodyPr>
+          <a:lstStyle/>
+          <a:p>
+            <a:pPr algn="l">
+              <a:lnSpc>
+                <a:spcPct val="135000"/>
+              </a:lnSpc>
+            </a:pPr>
+            <a:r>
+              <a:rPr sz="1300" b="1" i="0" spc="156">
+                <a:solidFill>
+                  <a:srgbClr val="A5335F"/>
+                </a:solidFill>
+                <a:latin typeface="Verdana"/>
+              </a:rPr>
+              <a:t>CE QU'ON N'A PAS RETIRÉ</a:t>
+            </a:r>
+          </a:p>
+        </p:txBody>
+      </p:sp>
+      <p:sp>
+        <p:nvSpPr>
+          <p:cNvPr id="6" name="TextBox 5"/>
+          <p:cNvSpPr txBox="1"/>
+          <p:nvPr/>
+        </p:nvSpPr>
+        <p:spPr>
+          <a:xfrm>
+            <a:off x="566928" y="749808"/>
+            <a:ext cx="11057839" cy="877824"/>
+          </a:xfrm>
+          <a:prstGeom prst="rect">
+            <a:avLst/>
+          </a:prstGeom>
+          <a:noFill/>
+        </p:spPr>
+        <p:txBody>
+          <a:bodyPr wrap="square" lIns="0" rIns="0" tIns="0" bIns="0" anchor="t">
+            <a:spAutoFit/>
+          </a:bodyPr>
+          <a:lstStyle/>
+          <a:p>
+            <a:pPr algn="l">
+              <a:lnSpc>
+                <a:spcPct val="115000"/>
+              </a:lnSpc>
+            </a:pPr>
+            <a:r>
+              <a:rPr sz="3400" b="1" i="0">
+                <a:solidFill>
+                  <a:srgbClr val="17181A"/>
+                </a:solidFill>
+                <a:latin typeface="Verdana"/>
+              </a:rPr>
+              <a:t>Quatre choses qui restent, et c'est délibéré</a:t>
+            </a:r>
+          </a:p>
+        </p:txBody>
+      </p:sp>
+      <p:sp>
+        <p:nvSpPr>
+          <p:cNvPr id="7" name="Rounded Rectangle 6"/>
+          <p:cNvSpPr/>
+          <p:nvPr/>
+        </p:nvSpPr>
+        <p:spPr>
+          <a:xfrm>
+            <a:off x="566928" y="1810512"/>
+            <a:ext cx="5446623" cy="2052828"/>
+          </a:xfrm>
+          <a:prstGeom prst="roundRect">
+            <a:avLst>
+              <a:gd name="adj" fmla="val 7126"/>
+            </a:avLst>
+          </a:prstGeom>
+          <a:solidFill>
+            <a:srgbClr val="FFFFFF"/>
+          </a:solidFill>
+          <a:ln w="12700">
+            <a:solidFill>
+              <a:srgbClr val="EAEAE8"/>
+            </a:solidFill>
+          </a:ln>
+          <a:effectLst/>
+        </p:spPr>
+        <p:style>
+          <a:lnRef idx="1">
+            <a:schemeClr val="accent1"/>
+          </a:lnRef>
+          <a:fillRef idx="3">
+            <a:schemeClr val="accent1"/>
+          </a:fillRef>
+          <a:effectRef idx="2">
+            <a:schemeClr val="accent1"/>
+          </a:effectRef>
+          <a:fontRef idx="minor">
+            <a:schemeClr val="lt1"/>
+          </a:fontRef>
+        </p:style>
+        <p:txBody>
+          <a:bodyPr rtlCol="0" anchor="ctr"/>
+          <a:lstStyle/>
+          <a:p/>
+        </p:txBody>
+      </p:sp>
+      <p:sp>
+        <p:nvSpPr>
+          <p:cNvPr id="8" name="TextBox 7"/>
+          <p:cNvSpPr txBox="1"/>
+          <p:nvPr/>
+        </p:nvSpPr>
+        <p:spPr>
+          <a:xfrm>
+            <a:off x="886968" y="2084831"/>
+            <a:ext cx="4806543" cy="387096"/>
+          </a:xfrm>
+          <a:prstGeom prst="rect">
+            <a:avLst/>
+          </a:prstGeom>
+          <a:noFill/>
+        </p:spPr>
+        <p:txBody>
+          <a:bodyPr wrap="square" lIns="0" rIns="0" tIns="0" bIns="0" anchor="t">
+            <a:spAutoFit/>
+          </a:bodyPr>
+          <a:lstStyle/>
+          <a:p>
+            <a:pPr algn="l">
+              <a:lnSpc>
+                <a:spcPct val="118000"/>
+              </a:lnSpc>
+            </a:pPr>
+            <a:r>
+              <a:rPr sz="2400" b="1" i="0">
+                <a:solidFill>
+                  <a:srgbClr val="A5335F"/>
+                </a:solidFill>
+                <a:latin typeface="Verdana"/>
+              </a:rPr>
+              <a:t>L'enseignant</a:t>
+            </a:r>
+          </a:p>
+        </p:txBody>
+      </p:sp>
+      <p:sp>
+        <p:nvSpPr>
+          <p:cNvPr id="9" name="TextBox 8"/>
+          <p:cNvSpPr txBox="1"/>
+          <p:nvPr/>
+        </p:nvSpPr>
+        <p:spPr>
+          <a:xfrm>
+            <a:off x="886968" y="2499360"/>
+            <a:ext cx="4806543" cy="1089660"/>
+          </a:xfrm>
+          <a:prstGeom prst="rect">
+            <a:avLst/>
+          </a:prstGeom>
+          <a:noFill/>
+        </p:spPr>
+        <p:txBody>
+          <a:bodyPr wrap="square" lIns="0" rIns="0" tIns="0" bIns="0" anchor="t">
+            <a:spAutoFit/>
+          </a:bodyPr>
+          <a:lstStyle/>
+          <a:p>
+            <a:pPr algn="l">
+              <a:lnSpc>
+                <a:spcPct val="142000"/>
+              </a:lnSpc>
+            </a:pPr>
+            <a:r>
+              <a:rPr sz="1800" b="0" i="0">
+                <a:solidFill>
+                  <a:srgbClr val="3A3D40"/>
+                </a:solidFill>
+                <a:latin typeface="Verdana"/>
+              </a:rPr>
+              <a:t>Rien ne s'ouvre tout seul à un élève. C'est l'enseignant qui date un module, choisit la séance, lit les productions.</a:t>
+            </a:r>
+          </a:p>
+        </p:txBody>
+      </p:sp>
+      <p:sp>
+        <p:nvSpPr>
+          <p:cNvPr id="10" name="Rounded Rectangle 9"/>
+          <p:cNvSpPr/>
+          <p:nvPr/>
+        </p:nvSpPr>
+        <p:spPr>
+          <a:xfrm>
+            <a:off x="6178143" y="1810512"/>
+            <a:ext cx="5446623" cy="2052828"/>
+          </a:xfrm>
+          <a:prstGeom prst="roundRect">
+            <a:avLst>
+              <a:gd name="adj" fmla="val 7126"/>
+            </a:avLst>
+          </a:prstGeom>
+          <a:solidFill>
+            <a:srgbClr val="FFFFFF"/>
+          </a:solidFill>
+          <a:ln w="12700">
+            <a:solidFill>
+              <a:srgbClr val="EAEAE8"/>
+            </a:solidFill>
+          </a:ln>
+          <a:effectLst/>
+        </p:spPr>
+        <p:style>
+          <a:lnRef idx="1">
+            <a:schemeClr val="accent1"/>
+          </a:lnRef>
+          <a:fillRef idx="3">
+            <a:schemeClr val="accent1"/>
+          </a:fillRef>
+          <a:effectRef idx="2">
+            <a:schemeClr val="accent1"/>
+          </a:effectRef>
+          <a:fontRef idx="minor">
+            <a:schemeClr val="lt1"/>
+          </a:fontRef>
+        </p:style>
+        <p:txBody>
+          <a:bodyPr rtlCol="0" anchor="ctr"/>
+          <a:lstStyle/>
+          <a:p/>
+        </p:txBody>
+      </p:sp>
+      <p:sp>
+        <p:nvSpPr>
+          <p:cNvPr id="11" name="TextBox 10"/>
+          <p:cNvSpPr txBox="1"/>
+          <p:nvPr/>
+        </p:nvSpPr>
+        <p:spPr>
+          <a:xfrm>
+            <a:off x="6498183" y="2084831"/>
+            <a:ext cx="4806543" cy="387096"/>
+          </a:xfrm>
+          <a:prstGeom prst="rect">
+            <a:avLst/>
+          </a:prstGeom>
+          <a:noFill/>
+        </p:spPr>
+        <p:txBody>
+          <a:bodyPr wrap="square" lIns="0" rIns="0" tIns="0" bIns="0" anchor="t">
+            <a:spAutoFit/>
+          </a:bodyPr>
+          <a:lstStyle/>
+          <a:p>
+            <a:pPr algn="l">
+              <a:lnSpc>
+                <a:spcPct val="118000"/>
+              </a:lnSpc>
+            </a:pPr>
+            <a:r>
+              <a:rPr sz="2400" b="1" i="0">
+                <a:solidFill>
+                  <a:srgbClr val="A5335F"/>
+                </a:solidFill>
+                <a:latin typeface="Verdana"/>
+              </a:rPr>
+              <a:t>Le papier</a:t>
+            </a:r>
+          </a:p>
+        </p:txBody>
+      </p:sp>
+      <p:sp>
+        <p:nvSpPr>
+          <p:cNvPr id="12" name="TextBox 11"/>
+          <p:cNvSpPr txBox="1"/>
+          <p:nvPr/>
+        </p:nvSpPr>
+        <p:spPr>
+          <a:xfrm>
+            <a:off x="6498183" y="2499360"/>
+            <a:ext cx="4806543" cy="1089660"/>
+          </a:xfrm>
+          <a:prstGeom prst="rect">
+            <a:avLst/>
+          </a:prstGeom>
+          <a:noFill/>
+        </p:spPr>
+        <p:txBody>
+          <a:bodyPr wrap="square" lIns="0" rIns="0" tIns="0" bIns="0" anchor="t">
+            <a:spAutoFit/>
+          </a:bodyPr>
+          <a:lstStyle/>
+          <a:p>
+            <a:pPr algn="l">
+              <a:lnSpc>
+                <a:spcPct val="142000"/>
+              </a:lnSpc>
+            </a:pPr>
+            <a:r>
+              <a:rPr sz="1800" b="0" i="0">
+                <a:solidFill>
+                  <a:srgbClr val="3A3D40"/>
+                </a:solidFill>
+                <a:latin typeface="Verdana"/>
+              </a:rPr>
+              <a:t>1 264 fiches imprimables, noir et blanc. Un élève sans appareil fait la séance quand même.</a:t>
+            </a:r>
+          </a:p>
+        </p:txBody>
+      </p:sp>
+      <p:sp>
+        <p:nvSpPr>
+          <p:cNvPr id="13" name="Rounded Rectangle 12"/>
+          <p:cNvSpPr/>
+          <p:nvPr/>
+        </p:nvSpPr>
+        <p:spPr>
+          <a:xfrm>
+            <a:off x="566928" y="4027932"/>
+            <a:ext cx="5446623" cy="2052828"/>
+          </a:xfrm>
+          <a:prstGeom prst="roundRect">
+            <a:avLst>
+              <a:gd name="adj" fmla="val 7126"/>
+            </a:avLst>
+          </a:prstGeom>
+          <a:solidFill>
+            <a:srgbClr val="FFFFFF"/>
+          </a:solidFill>
+          <a:ln w="12700">
+            <a:solidFill>
+              <a:srgbClr val="EAEAE8"/>
+            </a:solidFill>
+          </a:ln>
+          <a:effectLst/>
+        </p:spPr>
+        <p:style>
+          <a:lnRef idx="1">
+            <a:schemeClr val="accent1"/>
+          </a:lnRef>
+          <a:fillRef idx="3">
+            <a:schemeClr val="accent1"/>
+          </a:fillRef>
+          <a:effectRef idx="2">
+            <a:schemeClr val="accent1"/>
+          </a:effectRef>
+          <a:fontRef idx="minor">
+            <a:schemeClr val="lt1"/>
+          </a:fontRef>
+        </p:style>
+        <p:txBody>
+          <a:bodyPr rtlCol="0" anchor="ctr"/>
+          <a:lstStyle/>
+          <a:p/>
+        </p:txBody>
+      </p:sp>
+      <p:sp>
+        <p:nvSpPr>
+          <p:cNvPr id="14" name="TextBox 13"/>
+          <p:cNvSpPr txBox="1"/>
+          <p:nvPr/>
+        </p:nvSpPr>
+        <p:spPr>
+          <a:xfrm>
+            <a:off x="886968" y="4302252"/>
+            <a:ext cx="4806543" cy="387096"/>
+          </a:xfrm>
+          <a:prstGeom prst="rect">
+            <a:avLst/>
+          </a:prstGeom>
+          <a:noFill/>
+        </p:spPr>
+        <p:txBody>
+          <a:bodyPr wrap="square" lIns="0" rIns="0" tIns="0" bIns="0" anchor="t">
+            <a:spAutoFit/>
+          </a:bodyPr>
+          <a:lstStyle/>
+          <a:p>
+            <a:pPr algn="l">
+              <a:lnSpc>
+                <a:spcPct val="118000"/>
+              </a:lnSpc>
+            </a:pPr>
+            <a:r>
+              <a:rPr sz="2400" b="1" i="0">
+                <a:solidFill>
+                  <a:srgbClr val="A5335F"/>
+                </a:solidFill>
+                <a:latin typeface="Verdana"/>
+              </a:rPr>
+              <a:t>La classe</a:t>
+            </a:r>
+          </a:p>
+        </p:txBody>
+      </p:sp>
+      <p:sp>
+        <p:nvSpPr>
+          <p:cNvPr id="15" name="TextBox 14"/>
+          <p:cNvSpPr txBox="1"/>
+          <p:nvPr/>
+        </p:nvSpPr>
+        <p:spPr>
+          <a:xfrm>
+            <a:off x="886968" y="4716780"/>
+            <a:ext cx="4806543" cy="1089660"/>
+          </a:xfrm>
+          <a:prstGeom prst="rect">
+            <a:avLst/>
+          </a:prstGeom>
+          <a:noFill/>
+        </p:spPr>
+        <p:txBody>
+          <a:bodyPr wrap="square" lIns="0" rIns="0" tIns="0" bIns="0" anchor="t">
+            <a:spAutoFit/>
+          </a:bodyPr>
+          <a:lstStyle/>
+          <a:p>
+            <a:pPr algn="l">
+              <a:lnSpc>
+                <a:spcPct val="142000"/>
+              </a:lnSpc>
+            </a:pPr>
+            <a:r>
+              <a:rPr sz="1800" b="0" i="0">
+                <a:solidFill>
+                  <a:srgbClr val="3A3D40"/>
+                </a:solidFill>
+                <a:latin typeface="Verdana"/>
+              </a:rPr>
+              <a:t>Le jeu de rôle a une moitié qui se joue à deux, en salle. Elle ne disparaît pas quand l'assistant est fermé.</a:t>
+            </a:r>
+          </a:p>
+        </p:txBody>
+      </p:sp>
+      <p:sp>
+        <p:nvSpPr>
+          <p:cNvPr id="16" name="Rounded Rectangle 15"/>
+          <p:cNvSpPr/>
+          <p:nvPr/>
+        </p:nvSpPr>
+        <p:spPr>
+          <a:xfrm>
+            <a:off x="6178143" y="4027932"/>
+            <a:ext cx="5446623" cy="2052828"/>
+          </a:xfrm>
+          <a:prstGeom prst="roundRect">
+            <a:avLst>
+              <a:gd name="adj" fmla="val 7126"/>
+            </a:avLst>
+          </a:prstGeom>
+          <a:solidFill>
+            <a:srgbClr val="FFFFFF"/>
+          </a:solidFill>
+          <a:ln w="12700">
+            <a:solidFill>
+              <a:srgbClr val="EAEAE8"/>
+            </a:solidFill>
+          </a:ln>
+          <a:effectLst/>
+        </p:spPr>
+        <p:style>
+          <a:lnRef idx="1">
+            <a:schemeClr val="accent1"/>
+          </a:lnRef>
+          <a:fillRef idx="3">
+            <a:schemeClr val="accent1"/>
+          </a:fillRef>
+          <a:effectRef idx="2">
+            <a:schemeClr val="accent1"/>
+          </a:effectRef>
+          <a:fontRef idx="minor">
+            <a:schemeClr val="lt1"/>
+          </a:fontRef>
+        </p:style>
+        <p:txBody>
+          <a:bodyPr rtlCol="0" anchor="ctr"/>
+          <a:lstStyle/>
+          <a:p/>
+        </p:txBody>
+      </p:sp>
+      <p:sp>
+        <p:nvSpPr>
+          <p:cNvPr id="17" name="TextBox 16"/>
+          <p:cNvSpPr txBox="1"/>
+          <p:nvPr/>
+        </p:nvSpPr>
+        <p:spPr>
+          <a:xfrm>
+            <a:off x="6498183" y="4302252"/>
+            <a:ext cx="4806543" cy="387096"/>
+          </a:xfrm>
+          <a:prstGeom prst="rect">
+            <a:avLst/>
+          </a:prstGeom>
+          <a:noFill/>
+        </p:spPr>
+        <p:txBody>
+          <a:bodyPr wrap="square" lIns="0" rIns="0" tIns="0" bIns="0" anchor="t">
+            <a:spAutoFit/>
+          </a:bodyPr>
+          <a:lstStyle/>
+          <a:p>
+            <a:pPr algn="l">
+              <a:lnSpc>
+                <a:spcPct val="118000"/>
+              </a:lnSpc>
+            </a:pPr>
+            <a:r>
+              <a:rPr sz="2400" b="1" i="0">
+                <a:solidFill>
+                  <a:srgbClr val="A5335F"/>
+                </a:solidFill>
+                <a:latin typeface="Verdana"/>
+              </a:rPr>
+              <a:t>Le droit de refuser</a:t>
+            </a:r>
+          </a:p>
+        </p:txBody>
+      </p:sp>
+      <p:sp>
+        <p:nvSpPr>
+          <p:cNvPr id="18" name="TextBox 17"/>
+          <p:cNvSpPr txBox="1"/>
+          <p:nvPr/>
+        </p:nvSpPr>
+        <p:spPr>
+          <a:xfrm>
+            <a:off x="6498183" y="4716780"/>
+            <a:ext cx="4806543" cy="1089660"/>
+          </a:xfrm>
+          <a:prstGeom prst="rect">
+            <a:avLst/>
+          </a:prstGeom>
+          <a:noFill/>
+        </p:spPr>
+        <p:txBody>
+          <a:bodyPr wrap="square" lIns="0" rIns="0" tIns="0" bIns="0" anchor="t">
+            <a:spAutoFit/>
+          </a:bodyPr>
+          <a:lstStyle/>
+          <a:p>
+            <a:pPr algn="l">
+              <a:lnSpc>
+                <a:spcPct val="142000"/>
+              </a:lnSpc>
+            </a:pPr>
+            <a:r>
+              <a:rPr sz="1800" b="0" i="0">
+                <a:solidFill>
+                  <a:srgbClr val="3A3D40"/>
+                </a:solidFill>
+                <a:latin typeface="Verdana"/>
+              </a:rPr>
+              <a:t>Un centre peut fermer l'assistant. Les 87 modules se replient : ce qui reste est un cours, pas une démo cassée.</a:t>
+            </a:r>
+          </a:p>
+        </p:txBody>
+      </p:sp>
+    </p:spTree>
+  </p:cSld>
+  <p:clrMapOvr>
+    <a:masterClrMapping/>
+  </p:clrMapOvr>
+</p:sld>
+</file>
+
+<file path=ppt/slides/slide16.xml><?xml version="1.0" encoding="utf-8"?>
+<p:sld xmlns:a="http://schemas.openxmlformats.org/drawingml/2006/main" xmlns:p="http://schemas.openxmlformats.org/presentationml/2006/main" xmlns:r="http://schemas.openxmlformats.org/officeDocument/2006/relationships">
+  <p:cSld>
+    <p:spTree>
+      <p:nvGrpSpPr>
+        <p:cNvPr id="1" name=""/>
+        <p:cNvGrpSpPr/>
+        <p:nvPr/>
+      </p:nvGrpSpPr>
+      <p:grpSpPr/>
+      <p:sp>
+        <p:nvSpPr>
+          <p:cNvPr id="2" name="Rectangle 1"/>
+          <p:cNvSpPr/>
+          <p:nvPr/>
+        </p:nvSpPr>
+        <p:spPr>
+          <a:xfrm>
+            <a:off x="0" y="0"/>
+            <a:ext cx="12191695" cy="6858000"/>
+          </a:xfrm>
+          <a:prstGeom prst="rect">
+            <a:avLst/>
+          </a:prstGeom>
+          <a:solidFill>
+            <a:srgbClr val="F7F7F5"/>
+          </a:solidFill>
+          <a:ln>
+            <a:noFill/>
+          </a:ln>
+          <a:effectLst/>
+        </p:spPr>
+        <p:style>
+          <a:lnRef idx="1">
+            <a:schemeClr val="accent1"/>
+          </a:lnRef>
+          <a:fillRef idx="3">
+            <a:schemeClr val="accent1"/>
+          </a:fillRef>
+          <a:effectRef idx="2">
+            <a:schemeClr val="accent1"/>
+          </a:effectRef>
+          <a:fontRef idx="minor">
+            <a:schemeClr val="lt1"/>
+          </a:fontRef>
+        </p:style>
+        <p:txBody>
+          <a:bodyPr rtlCol="0" anchor="ctr"/>
+          <a:lstStyle/>
+          <a:p/>
+        </p:txBody>
+      </p:sp>
+      <p:sp>
+        <p:nvSpPr>
+          <p:cNvPr id="3" name="TextBox 2"/>
+          <p:cNvSpPr txBox="1"/>
+          <p:nvPr/>
+        </p:nvSpPr>
+        <p:spPr>
+          <a:xfrm>
+            <a:off x="566928" y="6355080"/>
+            <a:ext cx="6400800" cy="219456"/>
+          </a:xfrm>
+          <a:prstGeom prst="rect">
+            <a:avLst/>
+          </a:prstGeom>
+          <a:noFill/>
+        </p:spPr>
+        <p:txBody>
+          <a:bodyPr wrap="square" lIns="0" rIns="0" tIns="0" bIns="0" anchor="t">
+            <a:spAutoFit/>
+          </a:bodyPr>
+          <a:lstStyle/>
+          <a:p>
+            <a:pPr algn="l">
+              <a:lnSpc>
+                <a:spcPct val="135000"/>
+              </a:lnSpc>
+            </a:pPr>
+            <a:r>
+              <a:rPr sz="1200" b="0" i="0">
+                <a:solidFill>
+                  <a:srgbClr val="6E7175"/>
+                </a:solidFill>
+                <a:latin typeface="Verdana"/>
+              </a:rPr>
+              <a:t>F1 · francis · présentation</a:t>
+            </a:r>
+          </a:p>
+        </p:txBody>
+      </p:sp>
+      <p:sp>
+        <p:nvSpPr>
+          <p:cNvPr id="4" name="TextBox 3"/>
+          <p:cNvSpPr txBox="1"/>
+          <p:nvPr/>
+        </p:nvSpPr>
+        <p:spPr>
+          <a:xfrm>
+            <a:off x="10710367" y="6355080"/>
+            <a:ext cx="914400" cy="219456"/>
+          </a:xfrm>
+          <a:prstGeom prst="rect">
+            <a:avLst/>
+          </a:prstGeom>
+          <a:noFill/>
+        </p:spPr>
+        <p:txBody>
+          <a:bodyPr wrap="square" lIns="0" rIns="0" tIns="0" bIns="0" anchor="t">
+            <a:spAutoFit/>
+          </a:bodyPr>
+          <a:lstStyle/>
+          <a:p>
+            <a:pPr algn="r">
+              <a:lnSpc>
+                <a:spcPct val="135000"/>
+              </a:lnSpc>
+            </a:pPr>
+            <a:r>
+              <a:rPr sz="1200" b="0" i="0">
+                <a:solidFill>
+                  <a:srgbClr val="6E7175"/>
+                </a:solidFill>
+                <a:latin typeface="Verdana"/>
+              </a:rPr>
+              <a:t>16</a:t>
+            </a:r>
+          </a:p>
+        </p:txBody>
+      </p:sp>
+      <p:sp>
+        <p:nvSpPr>
           <p:cNvPr id="5" name="Rectangle 4"/>
           <p:cNvSpPr/>
           <p:nvPr/>
@@ -11581,7 +11999,7 @@
                 </a:solidFill>
                 <a:latin typeface="Verdana"/>
               </a:rPr>
-              <a:t>LE MOMENT DE LA RÈGLE</a:t>
+              <a:t>LA FORME DES EXERCICES</a:t>
             </a:r>
           </a:p>
         </p:txBody>
@@ -11595,11 +12013,11 @@
         <p:spPr>
           <a:xfrm>
             <a:off x="566928" y="1225296"/>
-            <a:ext cx="11057839" cy="1967991"/>
+            <a:ext cx="11057839" cy="1441196"/>
           </a:xfrm>
           <a:prstGeom prst="roundRect">
             <a:avLst>
-              <a:gd name="adj" fmla="val 7434"/>
+              <a:gd name="adj" fmla="val 10151"/>
             </a:avLst>
           </a:prstGeom>
           <a:solidFill>
@@ -11641,7 +12059,7 @@
         <p:spPr>
           <a:xfrm>
             <a:off x="1298448" y="1682496"/>
-            <a:ext cx="9594799" cy="1145032"/>
+            <a:ext cx="9594799" cy="618235"/>
           </a:xfrm>
           <a:prstGeom prst="rect">
             <a:avLst/>
@@ -11666,7 +12084,7 @@
                 </a:solidFill>
                 <a:latin typeface="Verdana"/>
               </a:rPr>
-              <a:t>La règle arrive quand l'élève s'est trompé, jamais avant.</a:t>
+              <a:t>Sept familles, pas une de plus.</a:t>
             </a:r>
           </a:p>
         </p:txBody>
@@ -11679,12 +12097,12 @@
         </p:nvSpPr>
         <p:spPr>
           <a:xfrm>
-            <a:off x="566928" y="3467607"/>
-            <a:ext cx="11057839" cy="1671827"/>
+            <a:off x="566928" y="2940812"/>
+            <a:ext cx="11057839" cy="2040128"/>
           </a:xfrm>
           <a:prstGeom prst="roundRect">
             <a:avLst>
-              <a:gd name="adj" fmla="val 8751"/>
+              <a:gd name="adj" fmla="val 7171"/>
             </a:avLst>
           </a:prstGeom>
           <a:solidFill>
@@ -11725,8 +12143,8 @@
         </p:nvSpPr>
         <p:spPr>
           <a:xfrm>
-            <a:off x="969264" y="3741927"/>
-            <a:ext cx="10234879" cy="1214627"/>
+            <a:off x="969264" y="3215132"/>
+            <a:ext cx="10234879" cy="1582928"/>
           </a:xfrm>
           <a:prstGeom prst="rect">
             <a:avLst/>
@@ -11751,7 +12169,7 @@
                 </a:solidFill>
                 <a:latin typeface="Verdana"/>
               </a:rPr>
-              <a:t>Les mini-leçons ne sont pas en tête de module : elles s'ouvrent depuis l'exercice, au moment de l'erreur. Une règle lue avant d'en avoir eu besoin ne se retient pas — elle se recopie.</a:t>
+              <a:t>Vrai ou faux, associer, des cases à écrire, un texte à trous, des images, une question ouverte, un tableau. Un élève de francisation dépense beaucoup d'énergie à comprendre ce qu'on lui demande : il l'apprend une fois, puis il ne pense plus qu'au français.</a:t>
             </a:r>
           </a:p>
         </p:txBody>
@@ -11928,72 +12346,33 @@
                 </a:solidFill>
                 <a:latin typeface="Verdana"/>
               </a:rPr>
-              <a:t>CE QU'ON NOUS DIT</a:t>
-            </a:r>
-          </a:p>
-        </p:txBody>
-      </p:sp>
-      <p:sp>
-        <p:nvSpPr>
-          <p:cNvPr id="6" name="TextBox 5"/>
-          <p:cNvSpPr txBox="1"/>
-          <p:nvPr/>
-        </p:nvSpPr>
-        <p:spPr>
-          <a:xfrm>
-            <a:off x="566928" y="749808"/>
-            <a:ext cx="11057839" cy="877824"/>
-          </a:xfrm>
-          <a:prstGeom prst="rect">
-            <a:avLst/>
-          </a:prstGeom>
-          <a:noFill/>
-        </p:spPr>
-        <p:txBody>
-          <a:bodyPr wrap="square" lIns="0" rIns="0" tIns="0" bIns="0" anchor="t">
-            <a:spAutoFit/>
-          </a:bodyPr>
-          <a:lstStyle/>
-          <a:p>
-            <a:pPr algn="l">
-              <a:lnSpc>
-                <a:spcPct val="115000"/>
-              </a:lnSpc>
-            </a:pPr>
-            <a:r>
-              <a:rPr sz="3400" b="1" i="0">
-                <a:solidFill>
-                  <a:srgbClr val="17181A"/>
-                </a:solidFill>
-                <a:latin typeface="Verdana"/>
-              </a:rPr>
-              <a:t>Le piège le plus fréquent</a:t>
-            </a:r>
-          </a:p>
-        </p:txBody>
-      </p:sp>
-      <p:sp>
-        <p:nvSpPr>
-          <p:cNvPr id="7" name="Rounded Rectangle 6"/>
+              <a:t>LE MOMENT DE LA RÈGLE</a:t>
+            </a:r>
+          </a:p>
+        </p:txBody>
+      </p:sp>
+      <p:sp>
+        <p:nvSpPr>
+          <p:cNvPr id="6" name="Rounded Rectangle 5"/>
           <p:cNvSpPr/>
           <p:nvPr/>
         </p:nvSpPr>
         <p:spPr>
           <a:xfrm>
-            <a:off x="566928" y="1856232"/>
-            <a:ext cx="5428335" cy="2331720"/>
+            <a:off x="566928" y="1225296"/>
+            <a:ext cx="11057839" cy="1967991"/>
           </a:xfrm>
           <a:prstGeom prst="roundRect">
             <a:avLst>
-              <a:gd name="adj" fmla="val 6274"/>
+              <a:gd name="adj" fmla="val 7434"/>
             </a:avLst>
           </a:prstGeom>
           <a:solidFill>
-            <a:srgbClr val="FFF6F5"/>
+            <a:srgbClr val="FCE9F0"/>
           </a:solidFill>
           <a:ln w="12700">
             <a:solidFill>
-              <a:srgbClr val="DC2626"/>
+              <a:srgbClr val="EAEAE8"/>
             </a:solidFill>
           </a:ln>
           <a:effectLst/>
@@ -12020,14 +12399,14 @@
       </p:sp>
       <p:sp>
         <p:nvSpPr>
-          <p:cNvPr id="8" name="TextBox 7"/>
-          <p:cNvSpPr txBox="1"/>
-          <p:nvPr/>
-        </p:nvSpPr>
-        <p:spPr>
-          <a:xfrm>
-            <a:off x="932688" y="2130552"/>
-            <a:ext cx="4696815" cy="274320"/>
+          <p:cNvPr id="7" name="TextBox 6"/>
+          <p:cNvSpPr txBox="1"/>
+          <p:nvPr/>
+        </p:nvSpPr>
+        <p:spPr>
+          <a:xfrm>
+            <a:off x="1298448" y="1682496"/>
+            <a:ext cx="9594799" cy="1145032"/>
           </a:xfrm>
           <a:prstGeom prst="rect">
             <a:avLst/>
@@ -12042,198 +12421,35 @@
           <a:p>
             <a:pPr algn="l">
               <a:lnSpc>
-                <a:spcPct val="135000"/>
-              </a:lnSpc>
-            </a:pPr>
-            <a:r>
-              <a:rPr sz="1300" b="1" i="0" spc="156">
-                <a:solidFill>
-                  <a:srgbClr val="B91C1C"/>
-                </a:solidFill>
-                <a:latin typeface="Verdana"/>
-              </a:rPr>
-              <a:t>ON ENTEND SOUVENT</a:t>
-            </a:r>
-          </a:p>
-        </p:txBody>
-      </p:sp>
-      <p:sp>
-        <p:nvSpPr>
-          <p:cNvPr id="9" name="TextBox 8"/>
-          <p:cNvSpPr txBox="1"/>
-          <p:nvPr/>
-        </p:nvSpPr>
-        <p:spPr>
-          <a:xfrm>
-            <a:off x="932688" y="2569464"/>
-            <a:ext cx="4696815" cy="1417320"/>
-          </a:xfrm>
-          <a:prstGeom prst="rect">
-            <a:avLst/>
-          </a:prstGeom>
-          <a:noFill/>
-        </p:spPr>
-        <p:txBody>
-          <a:bodyPr wrap="square" lIns="0" rIns="0" tIns="0" bIns="0" anchor="t">
-            <a:spAutoFit/>
-          </a:bodyPr>
-          <a:lstStyle/>
-          <a:p>
-            <a:pPr algn="l">
-              <a:lnSpc>
-                <a:spcPct val="130000"/>
-              </a:lnSpc>
-            </a:pPr>
-            <a:r>
-              <a:rPr sz="2500" b="1" i="0">
+                <a:spcPct val="122000"/>
+              </a:lnSpc>
+            </a:pPr>
+            <a:r>
+              <a:rPr sz="3400" b="1" i="0">
                 <a:solidFill>
                   <a:srgbClr val="17181A"/>
                 </a:solidFill>
                 <a:latin typeface="Verdana"/>
               </a:rPr>
-              <a:t>« Si la machine corrige tout de suite, l'élève ne cherche plus. »</a:t>
-            </a:r>
-          </a:p>
-        </p:txBody>
-      </p:sp>
-      <p:sp>
-        <p:nvSpPr>
-          <p:cNvPr id="10" name="Rounded Rectangle 9"/>
+              <a:t>La règle arrive quand l'élève s'est trompé, jamais avant.</a:t>
+            </a:r>
+          </a:p>
+        </p:txBody>
+      </p:sp>
+      <p:sp>
+        <p:nvSpPr>
+          <p:cNvPr id="8" name="Rounded Rectangle 7"/>
           <p:cNvSpPr/>
           <p:nvPr/>
         </p:nvSpPr>
         <p:spPr>
           <a:xfrm>
-            <a:off x="6196431" y="1856232"/>
-            <a:ext cx="5428335" cy="2331720"/>
+            <a:off x="566928" y="3467607"/>
+            <a:ext cx="11057839" cy="1671827"/>
           </a:xfrm>
           <a:prstGeom prst="roundRect">
             <a:avLst>
-              <a:gd name="adj" fmla="val 6274"/>
-            </a:avLst>
-          </a:prstGeom>
-          <a:solidFill>
-            <a:srgbClr val="E6F5EE"/>
-          </a:solidFill>
-          <a:ln w="12700">
-            <a:solidFill>
-              <a:srgbClr val="0A8F5B"/>
-            </a:solidFill>
-          </a:ln>
-          <a:effectLst/>
-        </p:spPr>
-        <p:style>
-          <a:lnRef idx="1">
-            <a:schemeClr val="accent1"/>
-          </a:lnRef>
-          <a:fillRef idx="3">
-            <a:schemeClr val="accent1"/>
-          </a:fillRef>
-          <a:effectRef idx="2">
-            <a:schemeClr val="accent1"/>
-          </a:effectRef>
-          <a:fontRef idx="minor">
-            <a:schemeClr val="lt1"/>
-          </a:fontRef>
-        </p:style>
-        <p:txBody>
-          <a:bodyPr rtlCol="0" anchor="ctr"/>
-          <a:lstStyle/>
-          <a:p/>
-        </p:txBody>
-      </p:sp>
-      <p:sp>
-        <p:nvSpPr>
-          <p:cNvPr id="11" name="TextBox 10"/>
-          <p:cNvSpPr txBox="1"/>
-          <p:nvPr/>
-        </p:nvSpPr>
-        <p:spPr>
-          <a:xfrm>
-            <a:off x="6562191" y="2130552"/>
-            <a:ext cx="4696815" cy="274320"/>
-          </a:xfrm>
-          <a:prstGeom prst="rect">
-            <a:avLst/>
-          </a:prstGeom>
-          <a:noFill/>
-        </p:spPr>
-        <p:txBody>
-          <a:bodyPr wrap="square" lIns="0" rIns="0" tIns="0" bIns="0" anchor="t">
-            <a:spAutoFit/>
-          </a:bodyPr>
-          <a:lstStyle/>
-          <a:p>
-            <a:pPr algn="l">
-              <a:lnSpc>
-                <a:spcPct val="135000"/>
-              </a:lnSpc>
-            </a:pPr>
-            <a:r>
-              <a:rPr sz="1300" b="1" i="0" spc="156">
-                <a:solidFill>
-                  <a:srgbClr val="07734A"/>
-                </a:solidFill>
-                <a:latin typeface="Verdana"/>
-              </a:rPr>
-              <a:t>IL FAUT DIRE PLUTÔT</a:t>
-            </a:r>
-          </a:p>
-        </p:txBody>
-      </p:sp>
-      <p:sp>
-        <p:nvSpPr>
-          <p:cNvPr id="12" name="TextBox 11"/>
-          <p:cNvSpPr txBox="1"/>
-          <p:nvPr/>
-        </p:nvSpPr>
-        <p:spPr>
-          <a:xfrm>
-            <a:off x="6562191" y="2569464"/>
-            <a:ext cx="4696815" cy="1417320"/>
-          </a:xfrm>
-          <a:prstGeom prst="rect">
-            <a:avLst/>
-          </a:prstGeom>
-          <a:noFill/>
-        </p:spPr>
-        <p:txBody>
-          <a:bodyPr wrap="square" lIns="0" rIns="0" tIns="0" bIns="0" anchor="t">
-            <a:spAutoFit/>
-          </a:bodyPr>
-          <a:lstStyle/>
-          <a:p>
-            <a:pPr algn="l">
-              <a:lnSpc>
-                <a:spcPct val="130000"/>
-              </a:lnSpc>
-            </a:pPr>
-            <a:r>
-              <a:rPr sz="2500" b="1" i="0">
-                <a:solidFill>
-                  <a:srgbClr val="17181A"/>
-                </a:solidFill>
-                <a:latin typeface="Verdana"/>
-              </a:rPr>
-              <a:t>« Elle ne donne pas la réponse au premier essai. »</a:t>
-            </a:r>
-          </a:p>
-        </p:txBody>
-      </p:sp>
-      <p:sp>
-        <p:nvSpPr>
-          <p:cNvPr id="13" name="Rounded Rectangle 12"/>
-          <p:cNvSpPr/>
-          <p:nvPr/>
-        </p:nvSpPr>
-        <p:spPr>
-          <a:xfrm>
-            <a:off x="566928" y="4462272"/>
-            <a:ext cx="11057839" cy="1618487"/>
-          </a:xfrm>
-          <a:prstGeom prst="roundRect">
-            <a:avLst>
-              <a:gd name="adj" fmla="val 9039"/>
+              <a:gd name="adj" fmla="val 8751"/>
             </a:avLst>
           </a:prstGeom>
           <a:solidFill>
@@ -12268,14 +12484,14 @@
       </p:sp>
       <p:sp>
         <p:nvSpPr>
-          <p:cNvPr id="14" name="TextBox 13"/>
-          <p:cNvSpPr txBox="1"/>
-          <p:nvPr/>
-        </p:nvSpPr>
-        <p:spPr>
-          <a:xfrm>
-            <a:off x="969264" y="4736592"/>
-            <a:ext cx="10234879" cy="1518920"/>
+          <p:cNvPr id="9" name="TextBox 8"/>
+          <p:cNvSpPr txBox="1"/>
+          <p:nvPr/>
+        </p:nvSpPr>
+        <p:spPr>
+          <a:xfrm>
+            <a:off x="969264" y="3741927"/>
+            <a:ext cx="10234879" cy="1214627"/>
           </a:xfrm>
           <a:prstGeom prst="rect">
             <a:avLst/>
@@ -12300,7 +12516,7 @@
                 </a:solidFill>
                 <a:latin typeface="Verdana"/>
               </a:rPr>
-              <a:t>Une réponse ouverte demande deux tentatives avant que la réponse attendue s'affiche. C'était une correction, pas un réglage d'origine : la première version donnait tout du premier coup, et on voyait des élèves valider n'importe quoi pour lire la solution.</a:t>
+              <a:t>Les mini-leçons ne sont pas en tête de module : elles s'ouvrent depuis l'exercice, au moment de l'erreur. Une règle lue avant d'en avoir eu besoin ne se retient pas — elle se recopie.</a:t>
             </a:r>
           </a:p>
         </p:txBody>
@@ -12477,33 +12693,72 @@
                 </a:solidFill>
                 <a:latin typeface="Verdana"/>
               </a:rPr>
-              <a:t>LA CORRECTION ET L'ENVOI</a:t>
-            </a:r>
-          </a:p>
-        </p:txBody>
-      </p:sp>
-      <p:sp>
-        <p:nvSpPr>
-          <p:cNvPr id="6" name="Rounded Rectangle 5"/>
+              <a:t>CE QU'ON NOUS DIT</a:t>
+            </a:r>
+          </a:p>
+        </p:txBody>
+      </p:sp>
+      <p:sp>
+        <p:nvSpPr>
+          <p:cNvPr id="6" name="TextBox 5"/>
+          <p:cNvSpPr txBox="1"/>
+          <p:nvPr/>
+        </p:nvSpPr>
+        <p:spPr>
+          <a:xfrm>
+            <a:off x="566928" y="749808"/>
+            <a:ext cx="11057839" cy="877824"/>
+          </a:xfrm>
+          <a:prstGeom prst="rect">
+            <a:avLst/>
+          </a:prstGeom>
+          <a:noFill/>
+        </p:spPr>
+        <p:txBody>
+          <a:bodyPr wrap="square" lIns="0" rIns="0" tIns="0" bIns="0" anchor="t">
+            <a:spAutoFit/>
+          </a:bodyPr>
+          <a:lstStyle/>
+          <a:p>
+            <a:pPr algn="l">
+              <a:lnSpc>
+                <a:spcPct val="115000"/>
+              </a:lnSpc>
+            </a:pPr>
+            <a:r>
+              <a:rPr sz="3400" b="1" i="0">
+                <a:solidFill>
+                  <a:srgbClr val="17181A"/>
+                </a:solidFill>
+                <a:latin typeface="Verdana"/>
+              </a:rPr>
+              <a:t>Le piège le plus fréquent</a:t>
+            </a:r>
+          </a:p>
+        </p:txBody>
+      </p:sp>
+      <p:sp>
+        <p:nvSpPr>
+          <p:cNvPr id="7" name="Rounded Rectangle 6"/>
           <p:cNvSpPr/>
           <p:nvPr/>
         </p:nvSpPr>
         <p:spPr>
           <a:xfrm>
-            <a:off x="566928" y="1225296"/>
-            <a:ext cx="11057839" cy="1967991"/>
+            <a:off x="566928" y="1856232"/>
+            <a:ext cx="5428335" cy="2331720"/>
           </a:xfrm>
           <a:prstGeom prst="roundRect">
             <a:avLst>
-              <a:gd name="adj" fmla="val 7434"/>
+              <a:gd name="adj" fmla="val 6274"/>
             </a:avLst>
           </a:prstGeom>
           <a:solidFill>
-            <a:srgbClr val="FCE9F0"/>
+            <a:srgbClr val="FFF6F5"/>
           </a:solidFill>
           <a:ln w="12700">
             <a:solidFill>
-              <a:srgbClr val="EAEAE8"/>
+              <a:srgbClr val="DC2626"/>
             </a:solidFill>
           </a:ln>
           <a:effectLst/>
@@ -12530,14 +12785,14 @@
       </p:sp>
       <p:sp>
         <p:nvSpPr>
-          <p:cNvPr id="7" name="TextBox 6"/>
-          <p:cNvSpPr txBox="1"/>
-          <p:nvPr/>
-        </p:nvSpPr>
-        <p:spPr>
-          <a:xfrm>
-            <a:off x="1298448" y="1682496"/>
-            <a:ext cx="9594799" cy="1145032"/>
+          <p:cNvPr id="8" name="TextBox 7"/>
+          <p:cNvSpPr txBox="1"/>
+          <p:nvPr/>
+        </p:nvSpPr>
+        <p:spPr>
+          <a:xfrm>
+            <a:off x="932688" y="2130552"/>
+            <a:ext cx="4696815" cy="274320"/>
           </a:xfrm>
           <a:prstGeom prst="rect">
             <a:avLst/>
@@ -12552,35 +12807,198 @@
           <a:p>
             <a:pPr algn="l">
               <a:lnSpc>
-                <a:spcPct val="122000"/>
-              </a:lnSpc>
-            </a:pPr>
-            <a:r>
-              <a:rPr sz="3400" b="1" i="0">
+                <a:spcPct val="135000"/>
+              </a:lnSpc>
+            </a:pPr>
+            <a:r>
+              <a:rPr sz="1300" b="1" i="0" spc="156">
+                <a:solidFill>
+                  <a:srgbClr val="B91C1C"/>
+                </a:solidFill>
+                <a:latin typeface="Verdana"/>
+              </a:rPr>
+              <a:t>ON ENTEND SOUVENT</a:t>
+            </a:r>
+          </a:p>
+        </p:txBody>
+      </p:sp>
+      <p:sp>
+        <p:nvSpPr>
+          <p:cNvPr id="9" name="TextBox 8"/>
+          <p:cNvSpPr txBox="1"/>
+          <p:nvPr/>
+        </p:nvSpPr>
+        <p:spPr>
+          <a:xfrm>
+            <a:off x="932688" y="2569464"/>
+            <a:ext cx="4696815" cy="1417320"/>
+          </a:xfrm>
+          <a:prstGeom prst="rect">
+            <a:avLst/>
+          </a:prstGeom>
+          <a:noFill/>
+        </p:spPr>
+        <p:txBody>
+          <a:bodyPr wrap="square" lIns="0" rIns="0" tIns="0" bIns="0" anchor="t">
+            <a:spAutoFit/>
+          </a:bodyPr>
+          <a:lstStyle/>
+          <a:p>
+            <a:pPr algn="l">
+              <a:lnSpc>
+                <a:spcPct val="130000"/>
+              </a:lnSpc>
+            </a:pPr>
+            <a:r>
+              <a:rPr sz="2500" b="1" i="0">
                 <a:solidFill>
                   <a:srgbClr val="17181A"/>
                 </a:solidFill>
                 <a:latin typeface="Verdana"/>
               </a:rPr>
-              <a:t>La correction est privée. L'envoi est un geste.</a:t>
-            </a:r>
-          </a:p>
-        </p:txBody>
-      </p:sp>
-      <p:sp>
-        <p:nvSpPr>
-          <p:cNvPr id="8" name="Rounded Rectangle 7"/>
+              <a:t>« Si la machine corrige tout de suite, l'élève ne cherche plus. »</a:t>
+            </a:r>
+          </a:p>
+        </p:txBody>
+      </p:sp>
+      <p:sp>
+        <p:nvSpPr>
+          <p:cNvPr id="10" name="Rounded Rectangle 9"/>
           <p:cNvSpPr/>
           <p:nvPr/>
         </p:nvSpPr>
         <p:spPr>
           <a:xfrm>
-            <a:off x="566928" y="3467607"/>
-            <a:ext cx="11057839" cy="1671827"/>
+            <a:off x="6196431" y="1856232"/>
+            <a:ext cx="5428335" cy="2331720"/>
           </a:xfrm>
           <a:prstGeom prst="roundRect">
             <a:avLst>
-              <a:gd name="adj" fmla="val 8751"/>
+              <a:gd name="adj" fmla="val 6274"/>
+            </a:avLst>
+          </a:prstGeom>
+          <a:solidFill>
+            <a:srgbClr val="E6F5EE"/>
+          </a:solidFill>
+          <a:ln w="12700">
+            <a:solidFill>
+              <a:srgbClr val="0A8F5B"/>
+            </a:solidFill>
+          </a:ln>
+          <a:effectLst/>
+        </p:spPr>
+        <p:style>
+          <a:lnRef idx="1">
+            <a:schemeClr val="accent1"/>
+          </a:lnRef>
+          <a:fillRef idx="3">
+            <a:schemeClr val="accent1"/>
+          </a:fillRef>
+          <a:effectRef idx="2">
+            <a:schemeClr val="accent1"/>
+          </a:effectRef>
+          <a:fontRef idx="minor">
+            <a:schemeClr val="lt1"/>
+          </a:fontRef>
+        </p:style>
+        <p:txBody>
+          <a:bodyPr rtlCol="0" anchor="ctr"/>
+          <a:lstStyle/>
+          <a:p/>
+        </p:txBody>
+      </p:sp>
+      <p:sp>
+        <p:nvSpPr>
+          <p:cNvPr id="11" name="TextBox 10"/>
+          <p:cNvSpPr txBox="1"/>
+          <p:nvPr/>
+        </p:nvSpPr>
+        <p:spPr>
+          <a:xfrm>
+            <a:off x="6562191" y="2130552"/>
+            <a:ext cx="4696815" cy="274320"/>
+          </a:xfrm>
+          <a:prstGeom prst="rect">
+            <a:avLst/>
+          </a:prstGeom>
+          <a:noFill/>
+        </p:spPr>
+        <p:txBody>
+          <a:bodyPr wrap="square" lIns="0" rIns="0" tIns="0" bIns="0" anchor="t">
+            <a:spAutoFit/>
+          </a:bodyPr>
+          <a:lstStyle/>
+          <a:p>
+            <a:pPr algn="l">
+              <a:lnSpc>
+                <a:spcPct val="135000"/>
+              </a:lnSpc>
+            </a:pPr>
+            <a:r>
+              <a:rPr sz="1300" b="1" i="0" spc="156">
+                <a:solidFill>
+                  <a:srgbClr val="07734A"/>
+                </a:solidFill>
+                <a:latin typeface="Verdana"/>
+              </a:rPr>
+              <a:t>IL FAUT DIRE PLUTÔT</a:t>
+            </a:r>
+          </a:p>
+        </p:txBody>
+      </p:sp>
+      <p:sp>
+        <p:nvSpPr>
+          <p:cNvPr id="12" name="TextBox 11"/>
+          <p:cNvSpPr txBox="1"/>
+          <p:nvPr/>
+        </p:nvSpPr>
+        <p:spPr>
+          <a:xfrm>
+            <a:off x="6562191" y="2569464"/>
+            <a:ext cx="4696815" cy="1417320"/>
+          </a:xfrm>
+          <a:prstGeom prst="rect">
+            <a:avLst/>
+          </a:prstGeom>
+          <a:noFill/>
+        </p:spPr>
+        <p:txBody>
+          <a:bodyPr wrap="square" lIns="0" rIns="0" tIns="0" bIns="0" anchor="t">
+            <a:spAutoFit/>
+          </a:bodyPr>
+          <a:lstStyle/>
+          <a:p>
+            <a:pPr algn="l">
+              <a:lnSpc>
+                <a:spcPct val="130000"/>
+              </a:lnSpc>
+            </a:pPr>
+            <a:r>
+              <a:rPr sz="2500" b="1" i="0">
+                <a:solidFill>
+                  <a:srgbClr val="17181A"/>
+                </a:solidFill>
+                <a:latin typeface="Verdana"/>
+              </a:rPr>
+              <a:t>« Elle ne donne pas la réponse au premier essai. »</a:t>
+            </a:r>
+          </a:p>
+        </p:txBody>
+      </p:sp>
+      <p:sp>
+        <p:nvSpPr>
+          <p:cNvPr id="13" name="Rounded Rectangle 12"/>
+          <p:cNvSpPr/>
+          <p:nvPr/>
+        </p:nvSpPr>
+        <p:spPr>
+          <a:xfrm>
+            <a:off x="566928" y="4462272"/>
+            <a:ext cx="11057839" cy="1618487"/>
+          </a:xfrm>
+          <a:prstGeom prst="roundRect">
+            <a:avLst>
+              <a:gd name="adj" fmla="val 9039"/>
             </a:avLst>
           </a:prstGeom>
           <a:solidFill>
@@ -12615,14 +13033,14 @@
       </p:sp>
       <p:sp>
         <p:nvSpPr>
-          <p:cNvPr id="9" name="TextBox 8"/>
-          <p:cNvSpPr txBox="1"/>
-          <p:nvPr/>
-        </p:nvSpPr>
-        <p:spPr>
-          <a:xfrm>
-            <a:off x="969264" y="3741927"/>
-            <a:ext cx="10234879" cy="1214627"/>
+          <p:cNvPr id="14" name="TextBox 13"/>
+          <p:cNvSpPr txBox="1"/>
+          <p:nvPr/>
+        </p:nvSpPr>
+        <p:spPr>
+          <a:xfrm>
+            <a:off x="969264" y="4736592"/>
+            <a:ext cx="10234879" cy="1518920"/>
           </a:xfrm>
           <a:prstGeom prst="rect">
             <a:avLst/>
@@ -12647,7 +13065,7 @@
                 </a:solidFill>
                 <a:latin typeface="Verdana"/>
               </a:rPr>
-              <a:t>Quand un élève fait relire son texte ou son enregistrement, rien n'est gardé et rien ne part. L'enseignant reçoit ce que l'élève décide de lui envoyer, quand il le décide. C'est ce qui permet de recommencer douze fois.</a:t>
+              <a:t>Une réponse ouverte demande deux tentatives avant que la réponse attendue s'affiche. C'était une correction, pas un réglage d'origine : la première version donnait tout du premier coup, et on voyait des élèves valider n'importe quoi pour lire la solution.</a:t>
             </a:r>
           </a:p>
         </p:txBody>

</xml_diff>